<commit_message>
docs: Work on github use presentation
</commit_message>
<xml_diff>
--- a/docs/github-integrations.pptx
+++ b/docs/github-integrations.pptx
@@ -5,20 +5,17 @@
     <p:sldMasterId id="2147483659" r:id="rId4"/>
   </p:sldMasterIdLst>
   <p:notesMasterIdLst>
-    <p:notesMasterId r:id="rId16"/>
+    <p:notesMasterId r:id="rId13"/>
   </p:notesMasterIdLst>
   <p:sldIdLst>
-    <p:sldId id="256" r:id="rId5"/>
-    <p:sldId id="257" r:id="rId6"/>
+    <p:sldId id="257" r:id="rId5"/>
+    <p:sldId id="260" r:id="rId6"/>
     <p:sldId id="266" r:id="rId7"/>
     <p:sldId id="267" r:id="rId8"/>
-    <p:sldId id="260" r:id="rId9"/>
-    <p:sldId id="258" r:id="rId10"/>
-    <p:sldId id="261" r:id="rId11"/>
-    <p:sldId id="264" r:id="rId12"/>
-    <p:sldId id="265" r:id="rId13"/>
-    <p:sldId id="262" r:id="rId14"/>
-    <p:sldId id="263" r:id="rId15"/>
+    <p:sldId id="268" r:id="rId9"/>
+    <p:sldId id="269" r:id="rId10"/>
+    <p:sldId id="270" r:id="rId11"/>
+    <p:sldId id="263" r:id="rId12"/>
   </p:sldIdLst>
   <p:sldSz cx="12192000" cy="6858000"/>
   <p:notesSz cx="6858000" cy="9144000"/>
@@ -221,7 +218,7 @@
             <a:fld id="{E9E32C28-69F2-7740-886A-6640583AD07B}" type="datetimeFigureOut">
               <a:rPr lang="en-US" smtClean="0"/>
               <a:pPr/>
-              <a:t>6/10/2026</a:t>
+              <a:t>6/16/2026</a:t>
             </a:fld>
             <a:endParaRPr lang="en-US"/>
           </a:p>
@@ -17659,10 +17656,10 @@
       </p:grpSpPr>
       <p:sp>
         <p:nvSpPr>
-          <p:cNvPr id="2" name="Text Placeholder 1">
+          <p:cNvPr id="9" name="Text Placeholder 8">
             <a:extLst>
               <a:ext uri="{FF2B5EF4-FFF2-40B4-BE49-F238E27FC236}">
-                <a16:creationId xmlns:a16="http://schemas.microsoft.com/office/drawing/2014/main" id="{FD0A11ED-F059-A3D2-C063-1FCB5197E636}"/>
+                <a16:creationId xmlns:a16="http://schemas.microsoft.com/office/drawing/2014/main" id="{AA210E8B-E0D7-CFBA-8FC8-7C116EE64E5A}"/>
               </a:ext>
             </a:extLst>
           </p:cNvPr>
@@ -17678,16 +17675,19 @@
           <a:bodyPr/>
           <a:lstStyle/>
           <a:p>
-            <a:endParaRPr lang="en-US"/>
+            <a:r>
+              <a:rPr lang="en-US" dirty="0"/>
+              <a:t>Streamlining Code, Design, and Production Workflows through Collaboration and Automation</a:t>
+            </a:r>
           </a:p>
         </p:txBody>
       </p:sp>
       <p:sp>
         <p:nvSpPr>
-          <p:cNvPr id="3" name="Text Placeholder 2">
+          <p:cNvPr id="10" name="Text Placeholder 9">
             <a:extLst>
               <a:ext uri="{FF2B5EF4-FFF2-40B4-BE49-F238E27FC236}">
-                <a16:creationId xmlns:a16="http://schemas.microsoft.com/office/drawing/2014/main" id="{7C1C78E7-1D3C-A328-49D6-401D3B62E85D}"/>
+                <a16:creationId xmlns:a16="http://schemas.microsoft.com/office/drawing/2014/main" id="{D7C3538D-1CFE-521B-4F59-A16E6DA745A1}"/>
               </a:ext>
             </a:extLst>
           </p:cNvPr>
@@ -17703,16 +17703,19 @@
           <a:bodyPr/>
           <a:lstStyle/>
           <a:p>
-            <a:endParaRPr lang="en-US"/>
+            <a:r>
+              <a:rPr lang="en-US" dirty="0"/>
+              <a:t>6/16/2026</a:t>
+            </a:r>
           </a:p>
         </p:txBody>
       </p:sp>
       <p:sp>
         <p:nvSpPr>
-          <p:cNvPr id="4" name="Text Placeholder 3">
+          <p:cNvPr id="11" name="Text Placeholder 10">
             <a:extLst>
               <a:ext uri="{FF2B5EF4-FFF2-40B4-BE49-F238E27FC236}">
-                <a16:creationId xmlns:a16="http://schemas.microsoft.com/office/drawing/2014/main" id="{76659BBE-EE72-BD2C-C794-F114461A7BD9}"/>
+                <a16:creationId xmlns:a16="http://schemas.microsoft.com/office/drawing/2014/main" id="{B2D0CFAE-3346-E8E3-F661-734B8DCAD856}"/>
               </a:ext>
             </a:extLst>
           </p:cNvPr>
@@ -17728,16 +17731,25 @@
           <a:bodyPr/>
           <a:lstStyle/>
           <a:p>
-            <a:endParaRPr lang="en-US"/>
+            <a:r>
+              <a:rPr lang="en-US" dirty="0"/>
+              <a:t>Aiden Cherniske</a:t>
+            </a:r>
+          </a:p>
+          <a:p>
+            <a:r>
+              <a:rPr lang="en-US" dirty="0"/>
+              <a:t>Intern – Electrical Engineering</a:t>
+            </a:r>
           </a:p>
         </p:txBody>
       </p:sp>
       <p:sp>
         <p:nvSpPr>
-          <p:cNvPr id="5" name="Title 4">
+          <p:cNvPr id="8" name="Title 7">
             <a:extLst>
               <a:ext uri="{FF2B5EF4-FFF2-40B4-BE49-F238E27FC236}">
-                <a16:creationId xmlns:a16="http://schemas.microsoft.com/office/drawing/2014/main" id="{960A9F4D-DE48-27C5-5B7C-067BB2C23B1D}"/>
+                <a16:creationId xmlns:a16="http://schemas.microsoft.com/office/drawing/2014/main" id="{91DB2C20-9BDC-2F01-08D3-E843063F8E34}"/>
               </a:ext>
             </a:extLst>
           </p:cNvPr>
@@ -17753,46 +17765,19 @@
           <a:bodyPr/>
           <a:lstStyle/>
           <a:p>
-            <a:endParaRPr lang="en-US"/>
+            <a:r>
+              <a:rPr lang="en-US" dirty="0"/>
+              <a:t>Leveraging GitHub for Better Development</a:t>
+            </a:r>
           </a:p>
         </p:txBody>
       </p:sp>
-    </p:spTree>
-    <p:extLst>
-      <p:ext uri="{BB962C8B-B14F-4D97-AF65-F5344CB8AC3E}">
-        <p14:creationId xmlns:p14="http://schemas.microsoft.com/office/powerpoint/2010/main" val="2145076821"/>
-      </p:ext>
-    </p:extLst>
-  </p:cSld>
-  <p:clrMapOvr>
-    <a:masterClrMapping/>
-  </p:clrMapOvr>
-</p:sld>
-</file>
-
-<file path=ppt/slides/slide10.xml><?xml version="1.0" encoding="utf-8"?>
-<p:sld xmlns:a="http://schemas.openxmlformats.org/drawingml/2006/main" xmlns:r="http://schemas.openxmlformats.org/officeDocument/2006/relationships" xmlns:p="http://schemas.openxmlformats.org/presentationml/2006/main">
-  <p:cSld>
-    <p:spTree>
-      <p:nvGrpSpPr>
-        <p:cNvPr id="1" name=""/>
-        <p:cNvGrpSpPr/>
-        <p:nvPr/>
-      </p:nvGrpSpPr>
-      <p:grpSpPr>
-        <a:xfrm>
-          <a:off x="0" y="0"/>
-          <a:ext cx="0" cy="0"/>
-          <a:chOff x="0" y="0"/>
-          <a:chExt cx="0" cy="0"/>
-        </a:xfrm>
-      </p:grpSpPr>
       <p:sp>
         <p:nvSpPr>
           <p:cNvPr id="2" name="Slide Number Placeholder 1">
             <a:extLst>
               <a:ext uri="{FF2B5EF4-FFF2-40B4-BE49-F238E27FC236}">
-                <a16:creationId xmlns:a16="http://schemas.microsoft.com/office/drawing/2014/main" id="{8E3911C5-99B8-7E8C-88CC-D249280E8B6D}"/>
+                <a16:creationId xmlns:a16="http://schemas.microsoft.com/office/drawing/2014/main" id="{35A53303-A4CA-496D-5ACC-557E0891FB48}"/>
               </a:ext>
             </a:extLst>
           </p:cNvPr>
@@ -17815,7 +17800,8 @@
           <a:p>
             <a:fld id="{7B8EE3F9-A947-5A4C-873E-0A1944126D5A}" type="slidenum">
               <a:rPr lang="en-US" smtClean="0"/>
-              <a:t>10</a:t>
+              <a:pPr/>
+              <a:t>1</a:t>
             </a:fld>
             <a:endParaRPr lang="en-US"/>
           </a:p>
@@ -17824,37 +17810,7 @@
     </p:spTree>
     <p:extLst>
       <p:ext uri="{BB962C8B-B14F-4D97-AF65-F5344CB8AC3E}">
-        <p14:creationId xmlns:p14="http://schemas.microsoft.com/office/powerpoint/2010/main" val="599509122"/>
-      </p:ext>
-    </p:extLst>
-  </p:cSld>
-  <p:clrMapOvr>
-    <a:masterClrMapping/>
-  </p:clrMapOvr>
-</p:sld>
-</file>
-
-<file path=ppt/slides/slide11.xml><?xml version="1.0" encoding="utf-8"?>
-<p:sld xmlns:a="http://schemas.openxmlformats.org/drawingml/2006/main" xmlns:r="http://schemas.openxmlformats.org/officeDocument/2006/relationships" xmlns:p="http://schemas.openxmlformats.org/presentationml/2006/main">
-  <p:cSld>
-    <p:spTree>
-      <p:nvGrpSpPr>
-        <p:cNvPr id="1" name=""/>
-        <p:cNvGrpSpPr/>
-        <p:nvPr/>
-      </p:nvGrpSpPr>
-      <p:grpSpPr>
-        <a:xfrm>
-          <a:off x="0" y="0"/>
-          <a:ext cx="0" cy="0"/>
-          <a:chOff x="0" y="0"/>
-          <a:chExt cx="0" cy="0"/>
-        </a:xfrm>
-      </p:grpSpPr>
-    </p:spTree>
-    <p:extLst>
-      <p:ext uri="{BB962C8B-B14F-4D97-AF65-F5344CB8AC3E}">
-        <p14:creationId xmlns:p14="http://schemas.microsoft.com/office/powerpoint/2010/main" val="569995853"/>
+        <p14:creationId xmlns:p14="http://schemas.microsoft.com/office/powerpoint/2010/main" val="4248147053"/>
       </p:ext>
     </p:extLst>
   </p:cSld>
@@ -17883,85 +17839,10 @@
       </p:grpSpPr>
       <p:sp>
         <p:nvSpPr>
-          <p:cNvPr id="9" name="Text Placeholder 8">
+          <p:cNvPr id="5" name="Title 4">
             <a:extLst>
               <a:ext uri="{FF2B5EF4-FFF2-40B4-BE49-F238E27FC236}">
-                <a16:creationId xmlns:a16="http://schemas.microsoft.com/office/drawing/2014/main" id="{AA210E8B-E0D7-CFBA-8FC8-7C116EE64E5A}"/>
-              </a:ext>
-            </a:extLst>
-          </p:cNvPr>
-          <p:cNvSpPr>
-            <a:spLocks noGrp="1"/>
-          </p:cNvSpPr>
-          <p:nvPr>
-            <p:ph type="body" sz="quarter" idx="10"/>
-          </p:nvPr>
-        </p:nvSpPr>
-        <p:spPr/>
-        <p:txBody>
-          <a:bodyPr/>
-          <a:lstStyle/>
-          <a:p>
-            <a:endParaRPr lang="en-US"/>
-          </a:p>
-        </p:txBody>
-      </p:sp>
-      <p:sp>
-        <p:nvSpPr>
-          <p:cNvPr id="10" name="Text Placeholder 9">
-            <a:extLst>
-              <a:ext uri="{FF2B5EF4-FFF2-40B4-BE49-F238E27FC236}">
-                <a16:creationId xmlns:a16="http://schemas.microsoft.com/office/drawing/2014/main" id="{D7C3538D-1CFE-521B-4F59-A16E6DA745A1}"/>
-              </a:ext>
-            </a:extLst>
-          </p:cNvPr>
-          <p:cNvSpPr>
-            <a:spLocks noGrp="1"/>
-          </p:cNvSpPr>
-          <p:nvPr>
-            <p:ph type="body" sz="quarter" idx="11"/>
-          </p:nvPr>
-        </p:nvSpPr>
-        <p:spPr/>
-        <p:txBody>
-          <a:bodyPr/>
-          <a:lstStyle/>
-          <a:p>
-            <a:endParaRPr lang="en-US"/>
-          </a:p>
-        </p:txBody>
-      </p:sp>
-      <p:sp>
-        <p:nvSpPr>
-          <p:cNvPr id="11" name="Text Placeholder 10">
-            <a:extLst>
-              <a:ext uri="{FF2B5EF4-FFF2-40B4-BE49-F238E27FC236}">
-                <a16:creationId xmlns:a16="http://schemas.microsoft.com/office/drawing/2014/main" id="{B2D0CFAE-3346-E8E3-F661-734B8DCAD856}"/>
-              </a:ext>
-            </a:extLst>
-          </p:cNvPr>
-          <p:cNvSpPr>
-            <a:spLocks noGrp="1"/>
-          </p:cNvSpPr>
-          <p:nvPr>
-            <p:ph type="body" sz="quarter" idx="12"/>
-          </p:nvPr>
-        </p:nvSpPr>
-        <p:spPr/>
-        <p:txBody>
-          <a:bodyPr/>
-          <a:lstStyle/>
-          <a:p>
-            <a:endParaRPr lang="en-US"/>
-          </a:p>
-        </p:txBody>
-      </p:sp>
-      <p:sp>
-        <p:nvSpPr>
-          <p:cNvPr id="8" name="Title 7">
-            <a:extLst>
-              <a:ext uri="{FF2B5EF4-FFF2-40B4-BE49-F238E27FC236}">
-                <a16:creationId xmlns:a16="http://schemas.microsoft.com/office/drawing/2014/main" id="{91DB2C20-9BDC-2F01-08D3-E843063F8E34}"/>
+                <a16:creationId xmlns:a16="http://schemas.microsoft.com/office/drawing/2014/main" id="{867B2AA1-5506-F8EF-AECF-19BC094E2931}"/>
               </a:ext>
             </a:extLst>
           </p:cNvPr>
@@ -17977,109 +17858,19 @@
           <a:bodyPr/>
           <a:lstStyle/>
           <a:p>
-            <a:endParaRPr lang="en-US"/>
+            <a:r>
+              <a:rPr lang="en-US" dirty="0"/>
+              <a:t>Current State of GitHub Utilization</a:t>
+            </a:r>
           </a:p>
         </p:txBody>
       </p:sp>
       <p:sp>
         <p:nvSpPr>
-          <p:cNvPr id="2" name="Slide Number Placeholder 1">
+          <p:cNvPr id="6" name="Content Placeholder 5">
             <a:extLst>
               <a:ext uri="{FF2B5EF4-FFF2-40B4-BE49-F238E27FC236}">
-                <a16:creationId xmlns:a16="http://schemas.microsoft.com/office/drawing/2014/main" id="{35A53303-A4CA-496D-5ACC-557E0891FB48}"/>
-              </a:ext>
-            </a:extLst>
-          </p:cNvPr>
-          <p:cNvSpPr>
-            <a:spLocks noGrp="1"/>
-          </p:cNvSpPr>
-          <p:nvPr>
-            <p:ph type="sldNum" sz="quarter" idx="4294967295"/>
-          </p:nvPr>
-        </p:nvSpPr>
-        <p:spPr>
-          <a:xfrm>
-            <a:off x="9448800" y="6356350"/>
-            <a:ext cx="2743200" cy="365125"/>
-          </a:xfrm>
-        </p:spPr>
-        <p:txBody>
-          <a:bodyPr/>
-          <a:lstStyle/>
-          <a:p>
-            <a:fld id="{7B8EE3F9-A947-5A4C-873E-0A1944126D5A}" type="slidenum">
-              <a:rPr lang="en-US" smtClean="0"/>
-              <a:pPr/>
-              <a:t>2</a:t>
-            </a:fld>
-            <a:endParaRPr lang="en-US"/>
-          </a:p>
-        </p:txBody>
-      </p:sp>
-    </p:spTree>
-    <p:extLst>
-      <p:ext uri="{BB962C8B-B14F-4D97-AF65-F5344CB8AC3E}">
-        <p14:creationId xmlns:p14="http://schemas.microsoft.com/office/powerpoint/2010/main" val="4248147053"/>
-      </p:ext>
-    </p:extLst>
-  </p:cSld>
-  <p:clrMapOvr>
-    <a:masterClrMapping/>
-  </p:clrMapOvr>
-</p:sld>
-</file>
-
-<file path=ppt/slides/slide3.xml><?xml version="1.0" encoding="utf-8"?>
-<p:sld xmlns:a="http://schemas.openxmlformats.org/drawingml/2006/main" xmlns:r="http://schemas.openxmlformats.org/officeDocument/2006/relationships" xmlns:p="http://schemas.openxmlformats.org/presentationml/2006/main">
-  <p:cSld>
-    <p:spTree>
-      <p:nvGrpSpPr>
-        <p:cNvPr id="1" name=""/>
-        <p:cNvGrpSpPr/>
-        <p:nvPr/>
-      </p:nvGrpSpPr>
-      <p:grpSpPr>
-        <a:xfrm>
-          <a:off x="0" y="0"/>
-          <a:ext cx="0" cy="0"/>
-          <a:chOff x="0" y="0"/>
-          <a:chExt cx="0" cy="0"/>
-        </a:xfrm>
-      </p:grpSpPr>
-      <p:sp>
-        <p:nvSpPr>
-          <p:cNvPr id="2" name="Title 1">
-            <a:extLst>
-              <a:ext uri="{FF2B5EF4-FFF2-40B4-BE49-F238E27FC236}">
-                <a16:creationId xmlns:a16="http://schemas.microsoft.com/office/drawing/2014/main" id="{F198F5BE-7A17-FEF2-2CE1-29065BCBD9A7}"/>
-              </a:ext>
-            </a:extLst>
-          </p:cNvPr>
-          <p:cNvSpPr>
-            <a:spLocks noGrp="1"/>
-          </p:cNvSpPr>
-          <p:nvPr>
-            <p:ph type="title"/>
-          </p:nvPr>
-        </p:nvSpPr>
-        <p:spPr/>
-        <p:txBody>
-          <a:bodyPr/>
-          <a:lstStyle/>
-          <a:p>
-            <a:r>
-              <a:rPr lang="en-US"/>
-              <a:t>Migrating existing presentations to this new template</a:t>
-            </a:r>
-          </a:p>
-        </p:txBody>
-      </p:sp>
-      <p:sp>
-        <p:nvSpPr>
-          <p:cNvPr id="3" name="Content Placeholder 2">
-            <a:extLst>
-              <a:ext uri="{FF2B5EF4-FFF2-40B4-BE49-F238E27FC236}">
-                <a16:creationId xmlns:a16="http://schemas.microsoft.com/office/drawing/2014/main" id="{0E43E2C9-FBED-21AC-C7E3-5A104A7E3FB3}"/>
+                <a16:creationId xmlns:a16="http://schemas.microsoft.com/office/drawing/2014/main" id="{7BED4890-E349-C21A-096D-2B37EB48E996}"/>
               </a:ext>
             </a:extLst>
           </p:cNvPr>
@@ -18092,154 +17883,73 @@
         </p:nvSpPr>
         <p:spPr/>
         <p:txBody>
-          <a:bodyPr>
-            <a:normAutofit fontScale="92500" lnSpcReduction="20000"/>
-          </a:bodyPr>
+          <a:bodyPr/>
           <a:lstStyle/>
           <a:p>
-            <a:pPr>
-              <a:buFont typeface="+mj-lt"/>
-              <a:buAutoNum type="arabicPeriod"/>
-            </a:pPr>
-            <a:r>
-              <a:rPr lang="en-US"/>
-              <a:t>Within the Coherent presentation, convert each slide to one of the slide layouts with the following names, as needed. (Tip: these are white slides with black titles and black logos; see next page.) </a:t>
-            </a:r>
-          </a:p>
-          <a:p>
-            <a:pPr lvl="1">
-              <a:buFont typeface="+mj-lt"/>
-              <a:buAutoNum type="alphaLcPeriod"/>
-            </a:pPr>
-            <a:r>
-              <a:rPr lang="en-US"/>
-              <a:t>Title Slide</a:t>
-            </a:r>
-          </a:p>
-          <a:p>
-            <a:pPr lvl="1">
-              <a:buFont typeface="+mj-lt"/>
-              <a:buAutoNum type="alphaLcPeriod"/>
-            </a:pPr>
-            <a:r>
-              <a:rPr lang="en-US"/>
-              <a:t>Section Header</a:t>
-            </a:r>
-          </a:p>
-          <a:p>
-            <a:pPr lvl="1">
-              <a:buFont typeface="+mj-lt"/>
-              <a:buAutoNum type="alphaLcPeriod"/>
-            </a:pPr>
-            <a:r>
-              <a:rPr lang="en-US"/>
-              <a:t>Single Column</a:t>
-            </a:r>
-          </a:p>
-          <a:p>
-            <a:pPr lvl="1">
-              <a:buFont typeface="+mj-lt"/>
-              <a:buAutoNum type="alphaLcPeriod"/>
-            </a:pPr>
-            <a:r>
-              <a:rPr lang="en-US"/>
-              <a:t>Double Column</a:t>
-            </a:r>
-          </a:p>
-          <a:p>
-            <a:pPr lvl="1">
-              <a:buFont typeface="+mj-lt"/>
-              <a:buAutoNum type="alphaLcPeriod"/>
-            </a:pPr>
-            <a:r>
-              <a:rPr lang="en-US"/>
-              <a:t>Title</a:t>
-            </a:r>
-          </a:p>
-          <a:p>
-            <a:pPr lvl="1">
-              <a:buFont typeface="+mj-lt"/>
-              <a:buAutoNum type="alphaLcPeriod"/>
-            </a:pPr>
-            <a:r>
-              <a:rPr lang="en-US"/>
-              <a:t>Column and Picture</a:t>
-            </a:r>
-          </a:p>
-          <a:p>
-            <a:pPr lvl="1">
-              <a:buFont typeface="+mj-lt"/>
-              <a:buAutoNum type="alphaLcPeriod"/>
-            </a:pPr>
-            <a:r>
-              <a:rPr lang="en-US"/>
-              <a:t>Blank</a:t>
-            </a:r>
-          </a:p>
-          <a:p>
-            <a:pPr lvl="1">
-              <a:buFont typeface="+mj-lt"/>
-              <a:buAutoNum type="alphaLcPeriod"/>
-            </a:pPr>
-            <a:r>
-              <a:rPr lang="en-US"/>
-              <a:t>End Slide</a:t>
-            </a:r>
-          </a:p>
-          <a:p>
-            <a:pPr lvl="1">
-              <a:buFont typeface="+mj-lt"/>
-              <a:buAutoNum type="alphaLcPeriod"/>
-            </a:pPr>
-            <a:r>
-              <a:rPr lang="en-US"/>
-              <a:t>Tag Line</a:t>
-            </a:r>
-          </a:p>
-          <a:p>
-            <a:pPr>
-              <a:buFont typeface="+mj-lt"/>
-              <a:buAutoNum type="arabicPeriod"/>
-            </a:pPr>
-            <a:r>
-              <a:rPr lang="en-US"/>
-              <a:t>These have corresponding slide layouts in this new PowerPoint template. Transferring your slides with the correct slide layout to the new template will convert them to the </a:t>
-            </a:r>
-            <a:r>
-              <a:rPr lang="en-US" err="1"/>
-              <a:t>Attalon</a:t>
-            </a:r>
-            <a:r>
-              <a:rPr lang="en-US"/>
-              <a:t> template. (Tip: if you see a Coherent logo in this new template, delete the slide, check Step 1 above, and re-transfer the slide.)</a:t>
-            </a:r>
-          </a:p>
-          <a:p>
-            <a:pPr>
-              <a:buFont typeface="+mj-lt"/>
-              <a:buAutoNum type="arabicPeriod"/>
-            </a:pPr>
-            <a:r>
-              <a:rPr lang="en-US"/>
-              <a:t>Once transferred to the </a:t>
-            </a:r>
-            <a:r>
-              <a:rPr lang="en-US" err="1"/>
-              <a:t>Attalon</a:t>
-            </a:r>
-            <a:r>
-              <a:rPr lang="en-US"/>
-              <a:t> template, each slide can then be edited as needed and converted to other slide layouts available in the new template, such as the dark layouts.</a:t>
-            </a:r>
-          </a:p>
-          <a:p>
-            <a:pPr>
-              <a:buFont typeface="+mj-lt"/>
-              <a:buAutoNum type="arabicPeriod"/>
-            </a:pPr>
-            <a:r>
-              <a:rPr lang="en-US"/>
-              <a:t>Still, it won’t be perfect. For assistance converting slides, contact Mark Lourie.</a:t>
+            <a:r>
+              <a:rPr lang="en-US" dirty="0"/>
+              <a:t>Migration of Historical Data</a:t>
+            </a:r>
+          </a:p>
+          <a:p>
+            <a:pPr lvl="1"/>
+            <a:r>
+              <a:rPr lang="en-US" dirty="0"/>
+              <a:t>S-Drive Storage</a:t>
+            </a:r>
+          </a:p>
+          <a:p>
+            <a:pPr lvl="1"/>
+            <a:r>
+              <a:rPr lang="en-US" dirty="0"/>
+              <a:t>Previous version control options</a:t>
+            </a:r>
+          </a:p>
+          <a:p>
+            <a:r>
+              <a:rPr lang="en-US" dirty="0"/>
+              <a:t>Repository Organization</a:t>
+            </a:r>
+          </a:p>
+          <a:p>
+            <a:pPr lvl="1"/>
+            <a:r>
+              <a:rPr lang="en-US" dirty="0"/>
+              <a:t>Core codebases for C, C#, Verilog, one off projects, etc.</a:t>
+            </a:r>
+          </a:p>
+          <a:p>
+            <a:pPr lvl="1"/>
+            <a:r>
+              <a:rPr lang="en-US" dirty="0"/>
+              <a:t>Legacy files which were previously scattered</a:t>
+            </a:r>
+          </a:p>
+          <a:p>
+            <a:r>
+              <a:rPr lang="en-US" dirty="0"/>
+              <a:t>Recent Development Progress</a:t>
+            </a:r>
+          </a:p>
+          <a:p>
+            <a:pPr lvl="1"/>
+            <a:r>
+              <a:rPr lang="en-US" dirty="0"/>
+              <a:t>Collaboration</a:t>
+            </a:r>
+          </a:p>
+          <a:p>
+            <a:pPr lvl="1"/>
+            <a:r>
+              <a:rPr lang="en-US" dirty="0"/>
+              <a:t>Basic workflow for version control</a:t>
+            </a:r>
+          </a:p>
+          <a:p>
+            <a:pPr lvl="1"/>
+            <a:r>
+              <a:rPr lang="en-US" dirty="0"/>
+              <a:t>Issue Tracking**</a:t>
             </a:r>
           </a:p>
         </p:txBody>
@@ -18249,7 +17959,7 @@
           <p:cNvPr id="4" name="Slide Number Placeholder 3">
             <a:extLst>
               <a:ext uri="{FF2B5EF4-FFF2-40B4-BE49-F238E27FC236}">
-                <a16:creationId xmlns:a16="http://schemas.microsoft.com/office/drawing/2014/main" id="{BAF96BB6-F130-FC16-D6F0-5AC5AF729F65}"/>
+                <a16:creationId xmlns:a16="http://schemas.microsoft.com/office/drawing/2014/main" id="{0E757C45-1C6B-16BB-3EA5-4AFF9FE3ADC3}"/>
               </a:ext>
             </a:extLst>
           </p:cNvPr>
@@ -18268,888 +17978,7 @@
             <a:fld id="{7B8EE3F9-A947-5A4C-873E-0A1944126D5A}" type="slidenum">
               <a:rPr lang="en-US" smtClean="0"/>
               <a:pPr/>
-              <a:t>3</a:t>
-            </a:fld>
-            <a:endParaRPr lang="en-US"/>
-          </a:p>
-        </p:txBody>
-      </p:sp>
-    </p:spTree>
-    <p:extLst>
-      <p:ext uri="{BB962C8B-B14F-4D97-AF65-F5344CB8AC3E}">
-        <p14:creationId xmlns:p14="http://schemas.microsoft.com/office/powerpoint/2010/main" val="281495701"/>
-      </p:ext>
-    </p:extLst>
-  </p:cSld>
-  <p:clrMapOvr>
-    <a:masterClrMapping/>
-  </p:clrMapOvr>
-</p:sld>
-</file>
-
-<file path=ppt/slides/slide4.xml><?xml version="1.0" encoding="utf-8"?>
-<p:sld xmlns:a="http://schemas.openxmlformats.org/drawingml/2006/main" xmlns:r="http://schemas.openxmlformats.org/officeDocument/2006/relationships" xmlns:p="http://schemas.openxmlformats.org/presentationml/2006/main">
-  <p:cSld>
-    <p:spTree>
-      <p:nvGrpSpPr>
-        <p:cNvPr id="1" name=""/>
-        <p:cNvGrpSpPr/>
-        <p:nvPr/>
-      </p:nvGrpSpPr>
-      <p:grpSpPr>
-        <a:xfrm>
-          <a:off x="0" y="0"/>
-          <a:ext cx="0" cy="0"/>
-          <a:chOff x="0" y="0"/>
-          <a:chExt cx="0" cy="0"/>
-        </a:xfrm>
-      </p:grpSpPr>
-      <p:sp>
-        <p:nvSpPr>
-          <p:cNvPr id="8" name="Text Placeholder 7">
-            <a:extLst>
-              <a:ext uri="{FF2B5EF4-FFF2-40B4-BE49-F238E27FC236}">
-                <a16:creationId xmlns:a16="http://schemas.microsoft.com/office/drawing/2014/main" id="{EBC45022-F681-ABCA-4F35-C9380CF3108C}"/>
-              </a:ext>
-            </a:extLst>
-          </p:cNvPr>
-          <p:cNvSpPr>
-            <a:spLocks noGrp="1"/>
-          </p:cNvSpPr>
-          <p:nvPr>
-            <p:ph type="body" sz="quarter" idx="10"/>
-          </p:nvPr>
-        </p:nvSpPr>
-        <p:spPr/>
-        <p:txBody>
-          <a:bodyPr/>
-          <a:lstStyle/>
-          <a:p>
-            <a:endParaRPr lang="en-US"/>
-          </a:p>
-        </p:txBody>
-      </p:sp>
-      <p:sp>
-        <p:nvSpPr>
-          <p:cNvPr id="9" name="Text Placeholder 8">
-            <a:extLst>
-              <a:ext uri="{FF2B5EF4-FFF2-40B4-BE49-F238E27FC236}">
-                <a16:creationId xmlns:a16="http://schemas.microsoft.com/office/drawing/2014/main" id="{A3707C6F-923E-C92A-1930-134403EEF811}"/>
-              </a:ext>
-            </a:extLst>
-          </p:cNvPr>
-          <p:cNvSpPr>
-            <a:spLocks noGrp="1"/>
-          </p:cNvSpPr>
-          <p:nvPr>
-            <p:ph type="body" sz="quarter" idx="11"/>
-          </p:nvPr>
-        </p:nvSpPr>
-        <p:spPr/>
-        <p:txBody>
-          <a:bodyPr/>
-          <a:lstStyle/>
-          <a:p>
-            <a:endParaRPr lang="en-US"/>
-          </a:p>
-        </p:txBody>
-      </p:sp>
-      <p:sp>
-        <p:nvSpPr>
-          <p:cNvPr id="18" name="Text Placeholder 17">
-            <a:extLst>
-              <a:ext uri="{FF2B5EF4-FFF2-40B4-BE49-F238E27FC236}">
-                <a16:creationId xmlns:a16="http://schemas.microsoft.com/office/drawing/2014/main" id="{944E6F39-289E-B6FE-5B9C-81701D19698C}"/>
-              </a:ext>
-            </a:extLst>
-          </p:cNvPr>
-          <p:cNvSpPr>
-            <a:spLocks noGrp="1"/>
-          </p:cNvSpPr>
-          <p:nvPr>
-            <p:ph type="body" sz="quarter" idx="12"/>
-          </p:nvPr>
-        </p:nvSpPr>
-        <p:spPr/>
-        <p:txBody>
-          <a:bodyPr/>
-          <a:lstStyle/>
-          <a:p>
-            <a:endParaRPr lang="en-US"/>
-          </a:p>
-        </p:txBody>
-      </p:sp>
-      <p:sp>
-        <p:nvSpPr>
-          <p:cNvPr id="3" name="Title 2">
-            <a:extLst>
-              <a:ext uri="{FF2B5EF4-FFF2-40B4-BE49-F238E27FC236}">
-                <a16:creationId xmlns:a16="http://schemas.microsoft.com/office/drawing/2014/main" id="{C1AC44BA-B0FF-2E56-7111-7AFB1C361A67}"/>
-              </a:ext>
-            </a:extLst>
-          </p:cNvPr>
-          <p:cNvSpPr>
-            <a:spLocks noGrp="1"/>
-          </p:cNvSpPr>
-          <p:nvPr>
-            <p:ph type="title"/>
-          </p:nvPr>
-        </p:nvSpPr>
-        <p:spPr/>
-        <p:txBody>
-          <a:bodyPr/>
-          <a:lstStyle/>
-          <a:p>
-            <a:endParaRPr lang="en-US"/>
-          </a:p>
-        </p:txBody>
-      </p:sp>
-      <p:sp>
-        <p:nvSpPr>
-          <p:cNvPr id="4" name="Slide Number Placeholder 3">
-            <a:extLst>
-              <a:ext uri="{FF2B5EF4-FFF2-40B4-BE49-F238E27FC236}">
-                <a16:creationId xmlns:a16="http://schemas.microsoft.com/office/drawing/2014/main" id="{839C4422-C79B-8209-397A-CC80AFD08BAE}"/>
-              </a:ext>
-            </a:extLst>
-          </p:cNvPr>
-          <p:cNvSpPr>
-            <a:spLocks noGrp="1"/>
-          </p:cNvSpPr>
-          <p:nvPr>
-            <p:ph type="sldNum" sz="quarter" idx="4294967295"/>
-          </p:nvPr>
-        </p:nvSpPr>
-        <p:spPr>
-          <a:xfrm>
-            <a:off x="9448800" y="6356350"/>
-            <a:ext cx="2743200" cy="365125"/>
-          </a:xfrm>
-        </p:spPr>
-        <p:txBody>
-          <a:bodyPr/>
-          <a:lstStyle/>
-          <a:p>
-            <a:fld id="{7B8EE3F9-A947-5A4C-873E-0A1944126D5A}" type="slidenum">
-              <a:rPr lang="en-US" smtClean="0"/>
-              <a:pPr/>
-              <a:t>4</a:t>
-            </a:fld>
-            <a:endParaRPr lang="en-US"/>
-          </a:p>
-        </p:txBody>
-      </p:sp>
-      <p:pic>
-        <p:nvPicPr>
-          <p:cNvPr id="6" name="Picture 5" descr="A screenshot of a computer&#10;&#10;AI-generated content may be incorrect.">
-            <a:extLst>
-              <a:ext uri="{FF2B5EF4-FFF2-40B4-BE49-F238E27FC236}">
-                <a16:creationId xmlns:a16="http://schemas.microsoft.com/office/drawing/2014/main" id="{52DE4A4D-2356-A19B-1FA9-56FADD31D5A1}"/>
-              </a:ext>
-            </a:extLst>
-          </p:cNvPr>
-          <p:cNvPicPr>
-            <a:picLocks noChangeAspect="1"/>
-          </p:cNvPicPr>
-          <p:nvPr/>
-        </p:nvPicPr>
-        <p:blipFill>
-          <a:blip r:embed="rId2"/>
-          <a:stretch>
-            <a:fillRect/>
-          </a:stretch>
-        </p:blipFill>
-        <p:spPr>
-          <a:xfrm>
-            <a:off x="4601936" y="200025"/>
-            <a:ext cx="6667500" cy="6457950"/>
-          </a:xfrm>
-          <a:prstGeom prst="rect">
-            <a:avLst/>
-          </a:prstGeom>
-        </p:spPr>
-      </p:pic>
-      <p:sp>
-        <p:nvSpPr>
-          <p:cNvPr id="5" name="TextBox 4">
-            <a:extLst>
-              <a:ext uri="{FF2B5EF4-FFF2-40B4-BE49-F238E27FC236}">
-                <a16:creationId xmlns:a16="http://schemas.microsoft.com/office/drawing/2014/main" id="{6B412138-0EBB-681F-66F4-20AFA29A3E7C}"/>
-              </a:ext>
-            </a:extLst>
-          </p:cNvPr>
-          <p:cNvSpPr txBox="1"/>
-          <p:nvPr/>
-        </p:nvSpPr>
-        <p:spPr>
-          <a:xfrm>
-            <a:off x="487680" y="925286"/>
-            <a:ext cx="3881573" cy="2308324"/>
-          </a:xfrm>
-          <a:prstGeom prst="rect">
-            <a:avLst/>
-          </a:prstGeom>
-          <a:noFill/>
-        </p:spPr>
-        <p:txBody>
-          <a:bodyPr wrap="square" rtlCol="0">
-            <a:spAutoFit/>
-          </a:bodyPr>
-          <a:lstStyle/>
-          <a:p>
-            <a:r>
-              <a:rPr lang="en-US"/>
-              <a:t>Ensure only these nine slide layouts are used in your existing presentation before migrating your slides to the </a:t>
-            </a:r>
-            <a:r>
-              <a:rPr lang="en-US" err="1"/>
-              <a:t>Attalon</a:t>
-            </a:r>
-            <a:r>
-              <a:rPr lang="en-US"/>
-              <a:t> slide deck.</a:t>
-            </a:r>
-          </a:p>
-          <a:p>
-            <a:endParaRPr lang="en-US"/>
-          </a:p>
-          <a:p>
-            <a:r>
-              <a:rPr lang="en-US" u="sng"/>
-              <a:t>Tip</a:t>
-            </a:r>
-            <a:r>
-              <a:rPr lang="en-US"/>
-              <a:t>: these are slide layouts with a black title and a black coherent logo. </a:t>
-            </a:r>
-          </a:p>
-        </p:txBody>
-      </p:sp>
-      <p:sp>
-        <p:nvSpPr>
-          <p:cNvPr id="7" name="Rectangle 6">
-            <a:extLst>
-              <a:ext uri="{FF2B5EF4-FFF2-40B4-BE49-F238E27FC236}">
-                <a16:creationId xmlns:a16="http://schemas.microsoft.com/office/drawing/2014/main" id="{5B602478-FB80-C260-C70E-D06C26978CE7}"/>
-              </a:ext>
-            </a:extLst>
-          </p:cNvPr>
-          <p:cNvSpPr/>
-          <p:nvPr/>
-        </p:nvSpPr>
-        <p:spPr>
-          <a:xfrm>
-            <a:off x="7162800" y="500743"/>
-            <a:ext cx="1317171" cy="1197428"/>
-          </a:xfrm>
-          <a:prstGeom prst="rect">
-            <a:avLst/>
-          </a:prstGeom>
-          <a:noFill/>
-          <a:ln w="38100">
-            <a:solidFill>
-              <a:schemeClr val="accent4"/>
-            </a:solidFill>
-          </a:ln>
-        </p:spPr>
-        <p:style>
-          <a:lnRef idx="2">
-            <a:schemeClr val="accent1">
-              <a:shade val="15000"/>
-            </a:schemeClr>
-          </a:lnRef>
-          <a:fillRef idx="1">
-            <a:schemeClr val="accent1"/>
-          </a:fillRef>
-          <a:effectRef idx="0">
-            <a:schemeClr val="accent1"/>
-          </a:effectRef>
-          <a:fontRef idx="minor">
-            <a:schemeClr val="lt1"/>
-          </a:fontRef>
-        </p:style>
-        <p:txBody>
-          <a:bodyPr rtlCol="0" anchor="ctr"/>
-          <a:lstStyle/>
-          <a:p>
-            <a:pPr algn="ctr"/>
-            <a:endParaRPr lang="en-US"/>
-          </a:p>
-        </p:txBody>
-      </p:sp>
-      <p:sp>
-        <p:nvSpPr>
-          <p:cNvPr id="10" name="Rectangle 9">
-            <a:extLst>
-              <a:ext uri="{FF2B5EF4-FFF2-40B4-BE49-F238E27FC236}">
-                <a16:creationId xmlns:a16="http://schemas.microsoft.com/office/drawing/2014/main" id="{82374377-6580-6785-BE44-4D18D91E6F60}"/>
-              </a:ext>
-            </a:extLst>
-          </p:cNvPr>
-          <p:cNvSpPr/>
-          <p:nvPr/>
-        </p:nvSpPr>
-        <p:spPr>
-          <a:xfrm>
-            <a:off x="2370365" y="955766"/>
-            <a:ext cx="1866356" cy="309154"/>
-          </a:xfrm>
-          <a:prstGeom prst="rect">
-            <a:avLst/>
-          </a:prstGeom>
-          <a:noFill/>
-          <a:ln w="38100">
-            <a:solidFill>
-              <a:schemeClr val="accent4"/>
-            </a:solidFill>
-          </a:ln>
-        </p:spPr>
-        <p:style>
-          <a:lnRef idx="2">
-            <a:schemeClr val="accent1">
-              <a:shade val="15000"/>
-            </a:schemeClr>
-          </a:lnRef>
-          <a:fillRef idx="1">
-            <a:schemeClr val="accent1"/>
-          </a:fillRef>
-          <a:effectRef idx="0">
-            <a:schemeClr val="accent1"/>
-          </a:effectRef>
-          <a:fontRef idx="minor">
-            <a:schemeClr val="lt1"/>
-          </a:fontRef>
-        </p:style>
-        <p:txBody>
-          <a:bodyPr rtlCol="0" anchor="ctr"/>
-          <a:lstStyle/>
-          <a:p>
-            <a:pPr algn="ctr"/>
-            <a:endParaRPr lang="en-US"/>
-          </a:p>
-        </p:txBody>
-      </p:sp>
-      <p:sp>
-        <p:nvSpPr>
-          <p:cNvPr id="11" name="Rectangle 10">
-            <a:extLst>
-              <a:ext uri="{FF2B5EF4-FFF2-40B4-BE49-F238E27FC236}">
-                <a16:creationId xmlns:a16="http://schemas.microsoft.com/office/drawing/2014/main" id="{794D05DE-B3C2-F78C-CD48-1407E912391B}"/>
-              </a:ext>
-            </a:extLst>
-          </p:cNvPr>
-          <p:cNvSpPr/>
-          <p:nvPr/>
-        </p:nvSpPr>
-        <p:spPr>
-          <a:xfrm>
-            <a:off x="4608735" y="1721754"/>
-            <a:ext cx="1317171" cy="1197428"/>
-          </a:xfrm>
-          <a:prstGeom prst="rect">
-            <a:avLst/>
-          </a:prstGeom>
-          <a:noFill/>
-          <a:ln w="38100">
-            <a:solidFill>
-              <a:schemeClr val="accent4"/>
-            </a:solidFill>
-          </a:ln>
-        </p:spPr>
-        <p:style>
-          <a:lnRef idx="2">
-            <a:schemeClr val="accent1">
-              <a:shade val="15000"/>
-            </a:schemeClr>
-          </a:lnRef>
-          <a:fillRef idx="1">
-            <a:schemeClr val="accent1"/>
-          </a:fillRef>
-          <a:effectRef idx="0">
-            <a:schemeClr val="accent1"/>
-          </a:effectRef>
-          <a:fontRef idx="minor">
-            <a:schemeClr val="lt1"/>
-          </a:fontRef>
-        </p:style>
-        <p:txBody>
-          <a:bodyPr rtlCol="0" anchor="ctr"/>
-          <a:lstStyle/>
-          <a:p>
-            <a:pPr algn="ctr"/>
-            <a:endParaRPr lang="en-US"/>
-          </a:p>
-        </p:txBody>
-      </p:sp>
-      <p:sp>
-        <p:nvSpPr>
-          <p:cNvPr id="12" name="Rectangle 11">
-            <a:extLst>
-              <a:ext uri="{FF2B5EF4-FFF2-40B4-BE49-F238E27FC236}">
-                <a16:creationId xmlns:a16="http://schemas.microsoft.com/office/drawing/2014/main" id="{5A0A7213-CB6F-7E5C-A949-8574FE43795D}"/>
-              </a:ext>
-            </a:extLst>
-          </p:cNvPr>
-          <p:cNvSpPr/>
-          <p:nvPr/>
-        </p:nvSpPr>
-        <p:spPr>
-          <a:xfrm>
-            <a:off x="9749519" y="1687284"/>
-            <a:ext cx="1317171" cy="1197428"/>
-          </a:xfrm>
-          <a:prstGeom prst="rect">
-            <a:avLst/>
-          </a:prstGeom>
-          <a:noFill/>
-          <a:ln w="38100">
-            <a:solidFill>
-              <a:schemeClr val="accent4"/>
-            </a:solidFill>
-          </a:ln>
-        </p:spPr>
-        <p:style>
-          <a:lnRef idx="2">
-            <a:schemeClr val="accent1">
-              <a:shade val="15000"/>
-            </a:schemeClr>
-          </a:lnRef>
-          <a:fillRef idx="1">
-            <a:schemeClr val="accent1"/>
-          </a:fillRef>
-          <a:effectRef idx="0">
-            <a:schemeClr val="accent1"/>
-          </a:effectRef>
-          <a:fontRef idx="minor">
-            <a:schemeClr val="lt1"/>
-          </a:fontRef>
-        </p:style>
-        <p:txBody>
-          <a:bodyPr rtlCol="0" anchor="ctr"/>
-          <a:lstStyle/>
-          <a:p>
-            <a:pPr algn="ctr"/>
-            <a:endParaRPr lang="en-US"/>
-          </a:p>
-        </p:txBody>
-      </p:sp>
-      <p:sp>
-        <p:nvSpPr>
-          <p:cNvPr id="13" name="Rectangle 12">
-            <a:extLst>
-              <a:ext uri="{FF2B5EF4-FFF2-40B4-BE49-F238E27FC236}">
-                <a16:creationId xmlns:a16="http://schemas.microsoft.com/office/drawing/2014/main" id="{620BBF82-DDC6-F3AA-45B5-7D872E4C2FA3}"/>
-              </a:ext>
-            </a:extLst>
-          </p:cNvPr>
-          <p:cNvSpPr/>
-          <p:nvPr/>
-        </p:nvSpPr>
-        <p:spPr>
-          <a:xfrm>
-            <a:off x="7158718" y="1698171"/>
-            <a:ext cx="1317171" cy="1197428"/>
-          </a:xfrm>
-          <a:prstGeom prst="rect">
-            <a:avLst/>
-          </a:prstGeom>
-          <a:noFill/>
-          <a:ln w="38100">
-            <a:solidFill>
-              <a:schemeClr val="accent4"/>
-            </a:solidFill>
-          </a:ln>
-        </p:spPr>
-        <p:style>
-          <a:lnRef idx="2">
-            <a:schemeClr val="accent1">
-              <a:shade val="15000"/>
-            </a:schemeClr>
-          </a:lnRef>
-          <a:fillRef idx="1">
-            <a:schemeClr val="accent1"/>
-          </a:fillRef>
-          <a:effectRef idx="0">
-            <a:schemeClr val="accent1"/>
-          </a:effectRef>
-          <a:fontRef idx="minor">
-            <a:schemeClr val="lt1"/>
-          </a:fontRef>
-        </p:style>
-        <p:txBody>
-          <a:bodyPr rtlCol="0" anchor="ctr"/>
-          <a:lstStyle/>
-          <a:p>
-            <a:pPr algn="ctr"/>
-            <a:endParaRPr lang="en-US"/>
-          </a:p>
-        </p:txBody>
-      </p:sp>
-      <p:sp>
-        <p:nvSpPr>
-          <p:cNvPr id="14" name="Rectangle 13">
-            <a:extLst>
-              <a:ext uri="{FF2B5EF4-FFF2-40B4-BE49-F238E27FC236}">
-                <a16:creationId xmlns:a16="http://schemas.microsoft.com/office/drawing/2014/main" id="{5315CE3A-4F87-ECB8-65B2-0447404FD5AA}"/>
-              </a:ext>
-            </a:extLst>
-          </p:cNvPr>
-          <p:cNvSpPr/>
-          <p:nvPr/>
-        </p:nvSpPr>
-        <p:spPr>
-          <a:xfrm>
-            <a:off x="9757683" y="2862942"/>
-            <a:ext cx="1317171" cy="1197428"/>
-          </a:xfrm>
-          <a:prstGeom prst="rect">
-            <a:avLst/>
-          </a:prstGeom>
-          <a:noFill/>
-          <a:ln w="38100">
-            <a:solidFill>
-              <a:schemeClr val="accent4"/>
-            </a:solidFill>
-          </a:ln>
-        </p:spPr>
-        <p:style>
-          <a:lnRef idx="2">
-            <a:schemeClr val="accent1">
-              <a:shade val="15000"/>
-            </a:schemeClr>
-          </a:lnRef>
-          <a:fillRef idx="1">
-            <a:schemeClr val="accent1"/>
-          </a:fillRef>
-          <a:effectRef idx="0">
-            <a:schemeClr val="accent1"/>
-          </a:effectRef>
-          <a:fontRef idx="minor">
-            <a:schemeClr val="lt1"/>
-          </a:fontRef>
-        </p:style>
-        <p:txBody>
-          <a:bodyPr rtlCol="0" anchor="ctr"/>
-          <a:lstStyle/>
-          <a:p>
-            <a:pPr algn="ctr"/>
-            <a:endParaRPr lang="en-US"/>
-          </a:p>
-        </p:txBody>
-      </p:sp>
-      <p:sp>
-        <p:nvSpPr>
-          <p:cNvPr id="15" name="Rectangle 14">
-            <a:extLst>
-              <a:ext uri="{FF2B5EF4-FFF2-40B4-BE49-F238E27FC236}">
-                <a16:creationId xmlns:a16="http://schemas.microsoft.com/office/drawing/2014/main" id="{0547888A-0023-F4BD-671A-6F469E5DE6A6}"/>
-              </a:ext>
-            </a:extLst>
-          </p:cNvPr>
-          <p:cNvSpPr/>
-          <p:nvPr/>
-        </p:nvSpPr>
-        <p:spPr>
-          <a:xfrm>
-            <a:off x="5885088" y="2862942"/>
-            <a:ext cx="1317171" cy="1197428"/>
-          </a:xfrm>
-          <a:prstGeom prst="rect">
-            <a:avLst/>
-          </a:prstGeom>
-          <a:noFill/>
-          <a:ln w="38100">
-            <a:solidFill>
-              <a:schemeClr val="accent4"/>
-            </a:solidFill>
-          </a:ln>
-        </p:spPr>
-        <p:style>
-          <a:lnRef idx="2">
-            <a:schemeClr val="accent1">
-              <a:shade val="15000"/>
-            </a:schemeClr>
-          </a:lnRef>
-          <a:fillRef idx="1">
-            <a:schemeClr val="accent1"/>
-          </a:fillRef>
-          <a:effectRef idx="0">
-            <a:schemeClr val="accent1"/>
-          </a:effectRef>
-          <a:fontRef idx="minor">
-            <a:schemeClr val="lt1"/>
-          </a:fontRef>
-        </p:style>
-        <p:txBody>
-          <a:bodyPr rtlCol="0" anchor="ctr"/>
-          <a:lstStyle/>
-          <a:p>
-            <a:pPr algn="ctr"/>
-            <a:endParaRPr lang="en-US"/>
-          </a:p>
-        </p:txBody>
-      </p:sp>
-      <p:sp>
-        <p:nvSpPr>
-          <p:cNvPr id="16" name="Rectangle 15">
-            <a:extLst>
-              <a:ext uri="{FF2B5EF4-FFF2-40B4-BE49-F238E27FC236}">
-                <a16:creationId xmlns:a16="http://schemas.microsoft.com/office/drawing/2014/main" id="{3A7B5969-6E4E-667C-7749-A0348E72F6AD}"/>
-              </a:ext>
-            </a:extLst>
-          </p:cNvPr>
-          <p:cNvSpPr/>
-          <p:nvPr/>
-        </p:nvSpPr>
-        <p:spPr>
-          <a:xfrm>
-            <a:off x="7162800" y="4060371"/>
-            <a:ext cx="1317171" cy="1197428"/>
-          </a:xfrm>
-          <a:prstGeom prst="rect">
-            <a:avLst/>
-          </a:prstGeom>
-          <a:noFill/>
-          <a:ln w="38100">
-            <a:solidFill>
-              <a:schemeClr val="accent4"/>
-            </a:solidFill>
-          </a:ln>
-        </p:spPr>
-        <p:style>
-          <a:lnRef idx="2">
-            <a:schemeClr val="accent1">
-              <a:shade val="15000"/>
-            </a:schemeClr>
-          </a:lnRef>
-          <a:fillRef idx="1">
-            <a:schemeClr val="accent1"/>
-          </a:fillRef>
-          <a:effectRef idx="0">
-            <a:schemeClr val="accent1"/>
-          </a:effectRef>
-          <a:fontRef idx="minor">
-            <a:schemeClr val="lt1"/>
-          </a:fontRef>
-        </p:style>
-        <p:txBody>
-          <a:bodyPr rtlCol="0" anchor="ctr"/>
-          <a:lstStyle/>
-          <a:p>
-            <a:pPr algn="ctr"/>
-            <a:endParaRPr lang="en-US"/>
-          </a:p>
-        </p:txBody>
-      </p:sp>
-      <p:sp>
-        <p:nvSpPr>
-          <p:cNvPr id="17" name="Rectangle 16">
-            <a:extLst>
-              <a:ext uri="{FF2B5EF4-FFF2-40B4-BE49-F238E27FC236}">
-                <a16:creationId xmlns:a16="http://schemas.microsoft.com/office/drawing/2014/main" id="{42D8EA9F-A72B-5A0D-BC8E-5C3C2CA0DCF0}"/>
-              </a:ext>
-            </a:extLst>
-          </p:cNvPr>
-          <p:cNvSpPr/>
-          <p:nvPr/>
-        </p:nvSpPr>
-        <p:spPr>
-          <a:xfrm>
-            <a:off x="4601936" y="5201558"/>
-            <a:ext cx="1317171" cy="1197428"/>
-          </a:xfrm>
-          <a:prstGeom prst="rect">
-            <a:avLst/>
-          </a:prstGeom>
-          <a:noFill/>
-          <a:ln w="38100">
-            <a:solidFill>
-              <a:schemeClr val="accent4"/>
-            </a:solidFill>
-          </a:ln>
-        </p:spPr>
-        <p:style>
-          <a:lnRef idx="2">
-            <a:schemeClr val="accent1">
-              <a:shade val="15000"/>
-            </a:schemeClr>
-          </a:lnRef>
-          <a:fillRef idx="1">
-            <a:schemeClr val="accent1"/>
-          </a:fillRef>
-          <a:effectRef idx="0">
-            <a:schemeClr val="accent1"/>
-          </a:effectRef>
-          <a:fontRef idx="minor">
-            <a:schemeClr val="lt1"/>
-          </a:fontRef>
-        </p:style>
-        <p:txBody>
-          <a:bodyPr rtlCol="0" anchor="ctr"/>
-          <a:lstStyle/>
-          <a:p>
-            <a:pPr algn="ctr"/>
-            <a:endParaRPr lang="en-US"/>
-          </a:p>
-        </p:txBody>
-      </p:sp>
-      <p:sp>
-        <p:nvSpPr>
-          <p:cNvPr id="2" name="Rectangle 1">
-            <a:extLst>
-              <a:ext uri="{FF2B5EF4-FFF2-40B4-BE49-F238E27FC236}">
-                <a16:creationId xmlns:a16="http://schemas.microsoft.com/office/drawing/2014/main" id="{E8CD6521-FD8E-A577-F8E0-AFD65E1F8574}"/>
-              </a:ext>
-            </a:extLst>
-          </p:cNvPr>
-          <p:cNvSpPr/>
-          <p:nvPr/>
-        </p:nvSpPr>
-        <p:spPr>
-          <a:xfrm>
-            <a:off x="8458746" y="2862942"/>
-            <a:ext cx="1317171" cy="1197428"/>
-          </a:xfrm>
-          <a:prstGeom prst="rect">
-            <a:avLst/>
-          </a:prstGeom>
-          <a:noFill/>
-          <a:ln w="38100">
-            <a:solidFill>
-              <a:schemeClr val="accent4"/>
-            </a:solidFill>
-          </a:ln>
-        </p:spPr>
-        <p:style>
-          <a:lnRef idx="2">
-            <a:schemeClr val="accent1">
-              <a:shade val="15000"/>
-            </a:schemeClr>
-          </a:lnRef>
-          <a:fillRef idx="1">
-            <a:schemeClr val="accent1"/>
-          </a:fillRef>
-          <a:effectRef idx="0">
-            <a:schemeClr val="accent1"/>
-          </a:effectRef>
-          <a:fontRef idx="minor">
-            <a:schemeClr val="lt1"/>
-          </a:fontRef>
-        </p:style>
-        <p:txBody>
-          <a:bodyPr rtlCol="0" anchor="ctr"/>
-          <a:lstStyle/>
-          <a:p>
-            <a:pPr algn="ctr"/>
-            <a:endParaRPr lang="en-US"/>
-          </a:p>
-        </p:txBody>
-      </p:sp>
-    </p:spTree>
-    <p:extLst>
-      <p:ext uri="{BB962C8B-B14F-4D97-AF65-F5344CB8AC3E}">
-        <p14:creationId xmlns:p14="http://schemas.microsoft.com/office/powerpoint/2010/main" val="2571287114"/>
-      </p:ext>
-    </p:extLst>
-  </p:cSld>
-  <p:clrMapOvr>
-    <a:masterClrMapping/>
-  </p:clrMapOvr>
-</p:sld>
-</file>
-
-<file path=ppt/slides/slide5.xml><?xml version="1.0" encoding="utf-8"?>
-<p:sld xmlns:a="http://schemas.openxmlformats.org/drawingml/2006/main" xmlns:r="http://schemas.openxmlformats.org/officeDocument/2006/relationships" xmlns:p="http://schemas.openxmlformats.org/presentationml/2006/main">
-  <p:cSld>
-    <p:spTree>
-      <p:nvGrpSpPr>
-        <p:cNvPr id="1" name=""/>
-        <p:cNvGrpSpPr/>
-        <p:nvPr/>
-      </p:nvGrpSpPr>
-      <p:grpSpPr>
-        <a:xfrm>
-          <a:off x="0" y="0"/>
-          <a:ext cx="0" cy="0"/>
-          <a:chOff x="0" y="0"/>
-          <a:chExt cx="0" cy="0"/>
-        </a:xfrm>
-      </p:grpSpPr>
-      <p:sp>
-        <p:nvSpPr>
-          <p:cNvPr id="5" name="Title 4">
-            <a:extLst>
-              <a:ext uri="{FF2B5EF4-FFF2-40B4-BE49-F238E27FC236}">
-                <a16:creationId xmlns:a16="http://schemas.microsoft.com/office/drawing/2014/main" id="{867B2AA1-5506-F8EF-AECF-19BC094E2931}"/>
-              </a:ext>
-            </a:extLst>
-          </p:cNvPr>
-          <p:cNvSpPr>
-            <a:spLocks noGrp="1"/>
-          </p:cNvSpPr>
-          <p:nvPr>
-            <p:ph type="title"/>
-          </p:nvPr>
-        </p:nvSpPr>
-        <p:spPr/>
-        <p:txBody>
-          <a:bodyPr/>
-          <a:lstStyle/>
-          <a:p>
-            <a:endParaRPr lang="en-US"/>
-          </a:p>
-        </p:txBody>
-      </p:sp>
-      <p:sp>
-        <p:nvSpPr>
-          <p:cNvPr id="6" name="Content Placeholder 5">
-            <a:extLst>
-              <a:ext uri="{FF2B5EF4-FFF2-40B4-BE49-F238E27FC236}">
-                <a16:creationId xmlns:a16="http://schemas.microsoft.com/office/drawing/2014/main" id="{7BED4890-E349-C21A-096D-2B37EB48E996}"/>
-              </a:ext>
-            </a:extLst>
-          </p:cNvPr>
-          <p:cNvSpPr>
-            <a:spLocks noGrp="1"/>
-          </p:cNvSpPr>
-          <p:nvPr>
-            <p:ph idx="1"/>
-          </p:nvPr>
-        </p:nvSpPr>
-        <p:spPr/>
-        <p:txBody>
-          <a:bodyPr/>
-          <a:lstStyle/>
-          <a:p>
-            <a:endParaRPr lang="en-US"/>
-          </a:p>
-        </p:txBody>
-      </p:sp>
-      <p:sp>
-        <p:nvSpPr>
-          <p:cNvPr id="4" name="Slide Number Placeholder 3">
-            <a:extLst>
-              <a:ext uri="{FF2B5EF4-FFF2-40B4-BE49-F238E27FC236}">
-                <a16:creationId xmlns:a16="http://schemas.microsoft.com/office/drawing/2014/main" id="{0E757C45-1C6B-16BB-3EA5-4AFF9FE3ADC3}"/>
-              </a:ext>
-            </a:extLst>
-          </p:cNvPr>
-          <p:cNvSpPr>
-            <a:spLocks noGrp="1"/>
-          </p:cNvSpPr>
-          <p:nvPr>
-            <p:ph type="sldNum" sz="quarter" idx="12"/>
-          </p:nvPr>
-        </p:nvSpPr>
-        <p:spPr/>
-        <p:txBody>
-          <a:bodyPr/>
-          <a:lstStyle/>
-          <a:p>
-            <a:fld id="{7B8EE3F9-A947-5A4C-873E-0A1944126D5A}" type="slidenum">
-              <a:rPr lang="en-US" smtClean="0"/>
-              <a:pPr/>
-              <a:t>5</a:t>
+              <a:t>2</a:t>
             </a:fld>
             <a:endParaRPr lang="en-US"/>
           </a:p>
@@ -19168,12 +17997,18 @@
 </p:sld>
 </file>
 
-<file path=ppt/slides/slide6.xml><?xml version="1.0" encoding="utf-8"?>
+<file path=ppt/slides/slide3.xml><?xml version="1.0" encoding="utf-8"?>
 <p:sld xmlns:a="http://schemas.openxmlformats.org/drawingml/2006/main" xmlns:r="http://schemas.openxmlformats.org/officeDocument/2006/relationships" xmlns:p="http://schemas.openxmlformats.org/presentationml/2006/main">
   <p:cSld>
     <p:spTree>
       <p:nvGrpSpPr>
-        <p:cNvPr id="1" name=""/>
+        <p:cNvPr id="1" name="">
+          <a:extLst>
+            <a:ext uri="{FF2B5EF4-FFF2-40B4-BE49-F238E27FC236}">
+              <a16:creationId xmlns:a16="http://schemas.microsoft.com/office/drawing/2014/main" id="{537CBB10-CC4B-AF2B-380B-5817FC92B9EE}"/>
+            </a:ext>
+          </a:extLst>
+        </p:cNvPr>
         <p:cNvGrpSpPr/>
         <p:nvPr/>
       </p:nvGrpSpPr>
@@ -19187,10 +18022,153 @@
       </p:grpSpPr>
       <p:sp>
         <p:nvSpPr>
-          <p:cNvPr id="2" name="Slide Number Placeholder 1">
+          <p:cNvPr id="5" name="Title 4">
             <a:extLst>
               <a:ext uri="{FF2B5EF4-FFF2-40B4-BE49-F238E27FC236}">
-                <a16:creationId xmlns:a16="http://schemas.microsoft.com/office/drawing/2014/main" id="{02AB3F95-D49E-CFE0-2A17-0F16DCAB7F2E}"/>
+                <a16:creationId xmlns:a16="http://schemas.microsoft.com/office/drawing/2014/main" id="{3F187EE8-2BD7-F833-B6CF-21D63AB5D833}"/>
+              </a:ext>
+            </a:extLst>
+          </p:cNvPr>
+          <p:cNvSpPr>
+            <a:spLocks noGrp="1"/>
+          </p:cNvSpPr>
+          <p:nvPr>
+            <p:ph type="title"/>
+          </p:nvPr>
+        </p:nvSpPr>
+        <p:spPr/>
+        <p:txBody>
+          <a:bodyPr/>
+          <a:lstStyle/>
+          <a:p>
+            <a:r>
+              <a:rPr lang="en-US" dirty="0"/>
+              <a:t>Background Experience</a:t>
+            </a:r>
+          </a:p>
+        </p:txBody>
+      </p:sp>
+      <p:sp>
+        <p:nvSpPr>
+          <p:cNvPr id="6" name="Content Placeholder 5">
+            <a:extLst>
+              <a:ext uri="{FF2B5EF4-FFF2-40B4-BE49-F238E27FC236}">
+                <a16:creationId xmlns:a16="http://schemas.microsoft.com/office/drawing/2014/main" id="{941C406E-3435-188B-66C8-98E203CC37FB}"/>
+              </a:ext>
+            </a:extLst>
+          </p:cNvPr>
+          <p:cNvSpPr>
+            <a:spLocks noGrp="1"/>
+          </p:cNvSpPr>
+          <p:nvPr>
+            <p:ph idx="1"/>
+          </p:nvPr>
+        </p:nvSpPr>
+        <p:spPr/>
+        <p:txBody>
+          <a:bodyPr/>
+          <a:lstStyle/>
+          <a:p>
+            <a:r>
+              <a:rPr lang="en-US" dirty="0"/>
+              <a:t>Managed nearly 30 different projects over GitHub</a:t>
+            </a:r>
+          </a:p>
+          <a:p>
+            <a:pPr lvl="1"/>
+            <a:r>
+              <a:rPr lang="en-US" dirty="0"/>
+              <a:t>Personal, Professional, and Open Source</a:t>
+            </a:r>
+          </a:p>
+          <a:p>
+            <a:pPr lvl="1"/>
+            <a:endParaRPr lang="en-US" dirty="0"/>
+          </a:p>
+          <a:p>
+            <a:r>
+              <a:rPr lang="en-US" dirty="0"/>
+              <a:t>Key Take Aways</a:t>
+            </a:r>
+          </a:p>
+          <a:p>
+            <a:pPr lvl="1"/>
+            <a:r>
+              <a:rPr lang="en-US" dirty="0"/>
+              <a:t>Testing for Software Development</a:t>
+            </a:r>
+          </a:p>
+          <a:p>
+            <a:pPr lvl="2"/>
+            <a:r>
+              <a:rPr lang="en-US" dirty="0"/>
+              <a:t>Automated testing</a:t>
+            </a:r>
+          </a:p>
+          <a:p>
+            <a:pPr lvl="2"/>
+            <a:r>
+              <a:rPr lang="en-US" dirty="0"/>
+              <a:t>Distribution and Deployment</a:t>
+            </a:r>
+          </a:p>
+          <a:p>
+            <a:pPr lvl="1"/>
+            <a:r>
+              <a:rPr lang="en-US" dirty="0"/>
+              <a:t>Static Analysis</a:t>
+            </a:r>
+          </a:p>
+          <a:p>
+            <a:pPr lvl="2"/>
+            <a:r>
+              <a:rPr lang="en-US" dirty="0"/>
+              <a:t>Linting, Validation </a:t>
+            </a:r>
+          </a:p>
+          <a:p>
+            <a:pPr lvl="1"/>
+            <a:r>
+              <a:rPr lang="en-US" dirty="0"/>
+              <a:t>Review</a:t>
+            </a:r>
+          </a:p>
+          <a:p>
+            <a:pPr lvl="2"/>
+            <a:r>
+              <a:rPr lang="en-US" dirty="0"/>
+              <a:t>Pull Request “templates” in PR descriptions for standardized review</a:t>
+            </a:r>
+          </a:p>
+          <a:p>
+            <a:pPr lvl="1"/>
+            <a:r>
+              <a:rPr lang="en-US" dirty="0"/>
+              <a:t>Continuous Integration (CI/CD)</a:t>
+            </a:r>
+          </a:p>
+          <a:p>
+            <a:pPr lvl="2"/>
+            <a:r>
+              <a:rPr lang="en-US" dirty="0"/>
+              <a:t>Build and Compile Automation</a:t>
+            </a:r>
+          </a:p>
+          <a:p>
+            <a:pPr lvl="2"/>
+            <a:r>
+              <a:rPr lang="en-US" dirty="0"/>
+              <a:t>Code Standards (clang-format or ASTYLE)</a:t>
+            </a:r>
+          </a:p>
+        </p:txBody>
+      </p:sp>
+      <p:sp>
+        <p:nvSpPr>
+          <p:cNvPr id="4" name="Slide Number Placeholder 3">
+            <a:extLst>
+              <a:ext uri="{FF2B5EF4-FFF2-40B4-BE49-F238E27FC236}">
+                <a16:creationId xmlns:a16="http://schemas.microsoft.com/office/drawing/2014/main" id="{53AB43A8-B4F1-AC69-49A4-801490499A23}"/>
               </a:ext>
             </a:extLst>
           </p:cNvPr>
@@ -19209,18 +18187,54 @@
             <a:fld id="{7B8EE3F9-A947-5A4C-873E-0A1944126D5A}" type="slidenum">
               <a:rPr lang="en-US" smtClean="0"/>
               <a:pPr/>
-              <a:t>6</a:t>
+              <a:t>3</a:t>
             </a:fld>
             <a:endParaRPr lang="en-US"/>
           </a:p>
         </p:txBody>
       </p:sp>
+    </p:spTree>
+    <p:extLst>
+      <p:ext uri="{BB962C8B-B14F-4D97-AF65-F5344CB8AC3E}">
+        <p14:creationId xmlns:p14="http://schemas.microsoft.com/office/powerpoint/2010/main" val="3323729737"/>
+      </p:ext>
+    </p:extLst>
+  </p:cSld>
+  <p:clrMapOvr>
+    <a:masterClrMapping/>
+  </p:clrMapOvr>
+</p:sld>
+</file>
+
+<file path=ppt/slides/slide4.xml><?xml version="1.0" encoding="utf-8"?>
+<p:sld xmlns:a="http://schemas.openxmlformats.org/drawingml/2006/main" xmlns:r="http://schemas.openxmlformats.org/officeDocument/2006/relationships" xmlns:p="http://schemas.openxmlformats.org/presentationml/2006/main">
+  <p:cSld>
+    <p:spTree>
+      <p:nvGrpSpPr>
+        <p:cNvPr id="1" name="">
+          <a:extLst>
+            <a:ext uri="{FF2B5EF4-FFF2-40B4-BE49-F238E27FC236}">
+              <a16:creationId xmlns:a16="http://schemas.microsoft.com/office/drawing/2014/main" id="{D62EE68B-D693-EAC7-DC53-BCD8235E115D}"/>
+            </a:ext>
+          </a:extLst>
+        </p:cNvPr>
+        <p:cNvGrpSpPr/>
+        <p:nvPr/>
+      </p:nvGrpSpPr>
+      <p:grpSpPr>
+        <a:xfrm>
+          <a:off x="0" y="0"/>
+          <a:ext cx="0" cy="0"/>
+          <a:chOff x="0" y="0"/>
+          <a:chExt cx="0" cy="0"/>
+        </a:xfrm>
+      </p:grpSpPr>
       <p:sp>
         <p:nvSpPr>
-          <p:cNvPr id="3" name="Title 2">
+          <p:cNvPr id="5" name="Title 4">
             <a:extLst>
               <a:ext uri="{FF2B5EF4-FFF2-40B4-BE49-F238E27FC236}">
-                <a16:creationId xmlns:a16="http://schemas.microsoft.com/office/drawing/2014/main" id="{D47B040A-66AC-6660-164D-ABF0D944158A}"/>
+                <a16:creationId xmlns:a16="http://schemas.microsoft.com/office/drawing/2014/main" id="{EC511DA6-A2BF-9CC1-D575-22600A71B0F3}"/>
               </a:ext>
             </a:extLst>
           </p:cNvPr>
@@ -19236,6 +18250,157 @@
           <a:bodyPr/>
           <a:lstStyle/>
           <a:p>
+            <a:r>
+              <a:rPr lang="en-US" dirty="0"/>
+              <a:t>Deployment: Release Distributions</a:t>
+            </a:r>
+          </a:p>
+        </p:txBody>
+      </p:sp>
+      <p:sp>
+        <p:nvSpPr>
+          <p:cNvPr id="6" name="Content Placeholder 5">
+            <a:extLst>
+              <a:ext uri="{FF2B5EF4-FFF2-40B4-BE49-F238E27FC236}">
+                <a16:creationId xmlns:a16="http://schemas.microsoft.com/office/drawing/2014/main" id="{A052EECA-CB71-3FE8-3522-EDC301012C7F}"/>
+              </a:ext>
+            </a:extLst>
+          </p:cNvPr>
+          <p:cNvSpPr>
+            <a:spLocks noGrp="1"/>
+          </p:cNvSpPr>
+          <p:nvPr>
+            <p:ph idx="1"/>
+          </p:nvPr>
+        </p:nvSpPr>
+        <p:spPr/>
+        <p:txBody>
+          <a:bodyPr/>
+          <a:lstStyle/>
+          <a:p>
+            <a:r>
+              <a:rPr lang="en-US" dirty="0"/>
+              <a:t>Release Management</a:t>
+            </a:r>
+          </a:p>
+          <a:p>
+            <a:pPr lvl="1"/>
+            <a:r>
+              <a:rPr lang="en-US" dirty="0"/>
+              <a:t>Automate packaging of applications into installer executables or Zip files</a:t>
+            </a:r>
+          </a:p>
+          <a:p>
+            <a:pPr lvl="1"/>
+            <a:r>
+              <a:rPr lang="en-US" dirty="0"/>
+              <a:t>GitHub Actions can tag releases based on version numbers directly from a branch</a:t>
+            </a:r>
+          </a:p>
+          <a:p>
+            <a:pPr lvl="2"/>
+            <a:r>
+              <a:rPr lang="en-US" dirty="0"/>
+              <a:t>Generate .exe files automatically </a:t>
+            </a:r>
+          </a:p>
+          <a:p>
+            <a:pPr lvl="2"/>
+            <a:r>
+              <a:rPr lang="en-US" dirty="0"/>
+              <a:t>Push test builds to staging environments</a:t>
+            </a:r>
+          </a:p>
+          <a:p>
+            <a:pPr lvl="1"/>
+            <a:r>
+              <a:rPr lang="en-US" dirty="0"/>
+              <a:t>Distribution</a:t>
+            </a:r>
+          </a:p>
+          <a:p>
+            <a:pPr lvl="2"/>
+            <a:r>
+              <a:rPr lang="en-US" dirty="0"/>
+              <a:t>Create custom download links within GitHub releases</a:t>
+            </a:r>
+          </a:p>
+          <a:p>
+            <a:pPr lvl="2"/>
+            <a:r>
+              <a:rPr lang="en-US" dirty="0"/>
+              <a:t>Store production ready apps directly in GitHub</a:t>
+            </a:r>
+          </a:p>
+          <a:p>
+            <a:r>
+              <a:rPr lang="en-US" dirty="0"/>
+              <a:t>Embedded projects</a:t>
+            </a:r>
+          </a:p>
+          <a:p>
+            <a:pPr lvl="1"/>
+            <a:r>
+              <a:rPr lang="en-US" dirty="0"/>
+              <a:t>Store binaries as releases</a:t>
+            </a:r>
+          </a:p>
+          <a:p>
+            <a:pPr lvl="2"/>
+            <a:r>
+              <a:rPr lang="en-US" dirty="0"/>
+              <a:t>Each release can be tagged with specific versions and changelogs</a:t>
+            </a:r>
+          </a:p>
+          <a:p>
+            <a:pPr lvl="1"/>
+            <a:r>
+              <a:rPr lang="en-US" dirty="0"/>
+              <a:t>Automate build environments</a:t>
+            </a:r>
+          </a:p>
+          <a:p>
+            <a:pPr lvl="2"/>
+            <a:r>
+              <a:rPr lang="en-US" dirty="0"/>
+              <a:t>GitHub can automate cross-compilation for processors (ARM, AVR, PIC)</a:t>
+            </a:r>
+          </a:p>
+          <a:p>
+            <a:pPr lvl="2"/>
+            <a:r>
+              <a:rPr lang="en-US" dirty="0"/>
+              <a:t>Run tests on emulators if physical hardware is unavailable</a:t>
+            </a:r>
+          </a:p>
+        </p:txBody>
+      </p:sp>
+      <p:sp>
+        <p:nvSpPr>
+          <p:cNvPr id="4" name="Slide Number Placeholder 3">
+            <a:extLst>
+              <a:ext uri="{FF2B5EF4-FFF2-40B4-BE49-F238E27FC236}">
+                <a16:creationId xmlns:a16="http://schemas.microsoft.com/office/drawing/2014/main" id="{9F1A7500-91AB-56E4-7368-94DA8D5D8BA7}"/>
+              </a:ext>
+            </a:extLst>
+          </p:cNvPr>
+          <p:cNvSpPr>
+            <a:spLocks noGrp="1"/>
+          </p:cNvSpPr>
+          <p:nvPr>
+            <p:ph type="sldNum" sz="quarter" idx="12"/>
+          </p:nvPr>
+        </p:nvSpPr>
+        <p:spPr/>
+        <p:txBody>
+          <a:bodyPr/>
+          <a:lstStyle/>
+          <a:p>
+            <a:fld id="{7B8EE3F9-A947-5A4C-873E-0A1944126D5A}" type="slidenum">
+              <a:rPr lang="en-US" smtClean="0"/>
+              <a:pPr/>
+              <a:t>4</a:t>
+            </a:fld>
             <a:endParaRPr lang="en-US"/>
           </a:p>
         </p:txBody>
@@ -19243,7 +18408,397 @@
     </p:spTree>
     <p:extLst>
       <p:ext uri="{BB962C8B-B14F-4D97-AF65-F5344CB8AC3E}">
-        <p14:creationId xmlns:p14="http://schemas.microsoft.com/office/powerpoint/2010/main" val="216914539"/>
+        <p14:creationId xmlns:p14="http://schemas.microsoft.com/office/powerpoint/2010/main" val="1690862668"/>
+      </p:ext>
+    </p:extLst>
+  </p:cSld>
+  <p:clrMapOvr>
+    <a:masterClrMapping/>
+  </p:clrMapOvr>
+</p:sld>
+</file>
+
+<file path=ppt/slides/slide5.xml><?xml version="1.0" encoding="utf-8"?>
+<p:sld xmlns:a="http://schemas.openxmlformats.org/drawingml/2006/main" xmlns:r="http://schemas.openxmlformats.org/officeDocument/2006/relationships" xmlns:p="http://schemas.openxmlformats.org/presentationml/2006/main">
+  <p:cSld>
+    <p:spTree>
+      <p:nvGrpSpPr>
+        <p:cNvPr id="1" name="">
+          <a:extLst>
+            <a:ext uri="{FF2B5EF4-FFF2-40B4-BE49-F238E27FC236}">
+              <a16:creationId xmlns:a16="http://schemas.microsoft.com/office/drawing/2014/main" id="{ABCA2548-B201-6561-AEA3-318FB1BFCBF6}"/>
+            </a:ext>
+          </a:extLst>
+        </p:cNvPr>
+        <p:cNvGrpSpPr/>
+        <p:nvPr/>
+      </p:nvGrpSpPr>
+      <p:grpSpPr>
+        <a:xfrm>
+          <a:off x="0" y="0"/>
+          <a:ext cx="0" cy="0"/>
+          <a:chOff x="0" y="0"/>
+          <a:chExt cx="0" cy="0"/>
+        </a:xfrm>
+      </p:grpSpPr>
+      <p:sp>
+        <p:nvSpPr>
+          <p:cNvPr id="5" name="Title 4">
+            <a:extLst>
+              <a:ext uri="{FF2B5EF4-FFF2-40B4-BE49-F238E27FC236}">
+                <a16:creationId xmlns:a16="http://schemas.microsoft.com/office/drawing/2014/main" id="{BD834503-C1C3-C779-BDCE-1B9BECECA1B4}"/>
+              </a:ext>
+            </a:extLst>
+          </p:cNvPr>
+          <p:cNvSpPr>
+            <a:spLocks noGrp="1"/>
+          </p:cNvSpPr>
+          <p:nvPr>
+            <p:ph type="title"/>
+          </p:nvPr>
+        </p:nvSpPr>
+        <p:spPr/>
+        <p:txBody>
+          <a:bodyPr/>
+          <a:lstStyle/>
+          <a:p>
+            <a:r>
+              <a:rPr lang="en-US" dirty="0"/>
+              <a:t>Documentation</a:t>
+            </a:r>
+          </a:p>
+        </p:txBody>
+      </p:sp>
+      <p:sp>
+        <p:nvSpPr>
+          <p:cNvPr id="6" name="Content Placeholder 5">
+            <a:extLst>
+              <a:ext uri="{FF2B5EF4-FFF2-40B4-BE49-F238E27FC236}">
+                <a16:creationId xmlns:a16="http://schemas.microsoft.com/office/drawing/2014/main" id="{E07D92F7-8E67-58DB-23E6-137DAF6FAD03}"/>
+              </a:ext>
+            </a:extLst>
+          </p:cNvPr>
+          <p:cNvSpPr>
+            <a:spLocks noGrp="1"/>
+          </p:cNvSpPr>
+          <p:nvPr>
+            <p:ph idx="1"/>
+          </p:nvPr>
+        </p:nvSpPr>
+        <p:spPr/>
+        <p:txBody>
+          <a:bodyPr/>
+          <a:lstStyle/>
+          <a:p>
+            <a:r>
+              <a:rPr lang="en-US" dirty="0"/>
+              <a:t>C#</a:t>
+            </a:r>
+          </a:p>
+          <a:p>
+            <a:pPr lvl="1"/>
+            <a:r>
+              <a:rPr lang="en-US" dirty="0" err="1"/>
+              <a:t>DocFX</a:t>
+            </a:r>
+            <a:r>
+              <a:rPr lang="en-US" dirty="0"/>
+              <a:t> – automatically generate technical documentation from your project comments and inline code summaries</a:t>
+            </a:r>
+          </a:p>
+          <a:p>
+            <a:pPr lvl="1"/>
+            <a:r>
+              <a:rPr lang="en-US" dirty="0"/>
+              <a:t>Convert documentation into sites (GitHub pages?) or portable PDFs with GitHub Actions</a:t>
+            </a:r>
+          </a:p>
+          <a:p>
+            <a:r>
+              <a:rPr lang="en-US" dirty="0"/>
+              <a:t>Embedded</a:t>
+            </a:r>
+          </a:p>
+          <a:p>
+            <a:pPr lvl="1"/>
+            <a:r>
+              <a:rPr lang="en-US" dirty="0" err="1"/>
+              <a:t>Doxygen</a:t>
+            </a:r>
+            <a:r>
+              <a:rPr lang="en-US" dirty="0"/>
+              <a:t> – generate technical guides, code outlines, and call trees</a:t>
+            </a:r>
+          </a:p>
+          <a:p>
+            <a:pPr lvl="1"/>
+            <a:r>
+              <a:rPr lang="en-US" dirty="0"/>
+              <a:t>GitHub Actions can regenerate documentation every time new code is merged into a branch</a:t>
+            </a:r>
+          </a:p>
+          <a:p>
+            <a:r>
+              <a:rPr lang="en-US" dirty="0"/>
+              <a:t>Hardware documentation</a:t>
+            </a:r>
+          </a:p>
+          <a:p>
+            <a:pPr lvl="1"/>
+            <a:r>
+              <a:rPr lang="en-US" dirty="0"/>
+              <a:t>Use GitHub Actions to generate:</a:t>
+            </a:r>
+          </a:p>
+          <a:p>
+            <a:pPr lvl="2"/>
+            <a:r>
+              <a:rPr lang="en-US" dirty="0"/>
+              <a:t>PDFs of PCB layouts, schematics, BOMS, etc.</a:t>
+            </a:r>
+          </a:p>
+          <a:p>
+            <a:pPr lvl="2"/>
+            <a:r>
+              <a:rPr lang="en-US" dirty="0"/>
+              <a:t>Gerber files and BOMs all ready for distribution</a:t>
+            </a:r>
+          </a:p>
+        </p:txBody>
+      </p:sp>
+      <p:sp>
+        <p:nvSpPr>
+          <p:cNvPr id="4" name="Slide Number Placeholder 3">
+            <a:extLst>
+              <a:ext uri="{FF2B5EF4-FFF2-40B4-BE49-F238E27FC236}">
+                <a16:creationId xmlns:a16="http://schemas.microsoft.com/office/drawing/2014/main" id="{9551375A-D030-202F-A44C-F497402A6F77}"/>
+              </a:ext>
+            </a:extLst>
+          </p:cNvPr>
+          <p:cNvSpPr>
+            <a:spLocks noGrp="1"/>
+          </p:cNvSpPr>
+          <p:nvPr>
+            <p:ph type="sldNum" sz="quarter" idx="12"/>
+          </p:nvPr>
+        </p:nvSpPr>
+        <p:spPr/>
+        <p:txBody>
+          <a:bodyPr/>
+          <a:lstStyle/>
+          <a:p>
+            <a:fld id="{7B8EE3F9-A947-5A4C-873E-0A1944126D5A}" type="slidenum">
+              <a:rPr lang="en-US" smtClean="0"/>
+              <a:pPr/>
+              <a:t>5</a:t>
+            </a:fld>
+            <a:endParaRPr lang="en-US"/>
+          </a:p>
+        </p:txBody>
+      </p:sp>
+    </p:spTree>
+    <p:extLst>
+      <p:ext uri="{BB962C8B-B14F-4D97-AF65-F5344CB8AC3E}">
+        <p14:creationId xmlns:p14="http://schemas.microsoft.com/office/powerpoint/2010/main" val="1782276885"/>
+      </p:ext>
+    </p:extLst>
+  </p:cSld>
+  <p:clrMapOvr>
+    <a:masterClrMapping/>
+  </p:clrMapOvr>
+</p:sld>
+</file>
+
+<file path=ppt/slides/slide6.xml><?xml version="1.0" encoding="utf-8"?>
+<p:sld xmlns:a="http://schemas.openxmlformats.org/drawingml/2006/main" xmlns:r="http://schemas.openxmlformats.org/officeDocument/2006/relationships" xmlns:p="http://schemas.openxmlformats.org/presentationml/2006/main">
+  <p:cSld>
+    <p:spTree>
+      <p:nvGrpSpPr>
+        <p:cNvPr id="1" name="">
+          <a:extLst>
+            <a:ext uri="{FF2B5EF4-FFF2-40B4-BE49-F238E27FC236}">
+              <a16:creationId xmlns:a16="http://schemas.microsoft.com/office/drawing/2014/main" id="{0C05F8A9-12C4-739C-F7EE-8C02391AD4D0}"/>
+            </a:ext>
+          </a:extLst>
+        </p:cNvPr>
+        <p:cNvGrpSpPr/>
+        <p:nvPr/>
+      </p:nvGrpSpPr>
+      <p:grpSpPr>
+        <a:xfrm>
+          <a:off x="0" y="0"/>
+          <a:ext cx="0" cy="0"/>
+          <a:chOff x="0" y="0"/>
+          <a:chExt cx="0" cy="0"/>
+        </a:xfrm>
+      </p:grpSpPr>
+      <p:sp>
+        <p:nvSpPr>
+          <p:cNvPr id="5" name="Title 4">
+            <a:extLst>
+              <a:ext uri="{FF2B5EF4-FFF2-40B4-BE49-F238E27FC236}">
+                <a16:creationId xmlns:a16="http://schemas.microsoft.com/office/drawing/2014/main" id="{26B32693-6DEA-1C47-009C-A9DF8813E0FE}"/>
+              </a:ext>
+            </a:extLst>
+          </p:cNvPr>
+          <p:cNvSpPr>
+            <a:spLocks noGrp="1"/>
+          </p:cNvSpPr>
+          <p:nvPr>
+            <p:ph type="title"/>
+          </p:nvPr>
+        </p:nvSpPr>
+        <p:spPr/>
+        <p:txBody>
+          <a:bodyPr/>
+          <a:lstStyle/>
+          <a:p>
+            <a:r>
+              <a:rPr lang="en-US" dirty="0"/>
+              <a:t>Integrating Ticketing for Cross-Team Collaboration</a:t>
+            </a:r>
+          </a:p>
+        </p:txBody>
+      </p:sp>
+      <p:sp>
+        <p:nvSpPr>
+          <p:cNvPr id="6" name="Content Placeholder 5">
+            <a:extLst>
+              <a:ext uri="{FF2B5EF4-FFF2-40B4-BE49-F238E27FC236}">
+                <a16:creationId xmlns:a16="http://schemas.microsoft.com/office/drawing/2014/main" id="{7E22AA67-2462-C417-BA01-C01E43BE6A0F}"/>
+              </a:ext>
+            </a:extLst>
+          </p:cNvPr>
+          <p:cNvSpPr>
+            <a:spLocks noGrp="1"/>
+          </p:cNvSpPr>
+          <p:nvPr>
+            <p:ph idx="1"/>
+          </p:nvPr>
+        </p:nvSpPr>
+        <p:spPr/>
+        <p:txBody>
+          <a:bodyPr/>
+          <a:lstStyle/>
+          <a:p>
+            <a:r>
+              <a:rPr lang="en-US" dirty="0"/>
+              <a:t>Challenges</a:t>
+            </a:r>
+          </a:p>
+          <a:p>
+            <a:pPr lvl="1"/>
+            <a:r>
+              <a:rPr lang="en-US" dirty="0"/>
+              <a:t>Teams outside of the EE group currently submit issues via fragmented systems (emails, conversations)</a:t>
+            </a:r>
+          </a:p>
+          <a:p>
+            <a:pPr lvl="1"/>
+            <a:r>
+              <a:rPr lang="en-US" dirty="0"/>
+              <a:t>Problems can get lost, are poorly tracked, and may go unsolved</a:t>
+            </a:r>
+          </a:p>
+          <a:p>
+            <a:r>
+              <a:rPr lang="en-US" dirty="0"/>
+              <a:t>The Vision</a:t>
+            </a:r>
+          </a:p>
+          <a:p>
+            <a:pPr lvl="1"/>
+            <a:r>
+              <a:rPr lang="en-US" dirty="0"/>
+              <a:t>Enable teams to submit software/firmware/hardware related tickets and feature requests directly to corresponding GitHub repositories and projects without requiring full access to the secure GitHub</a:t>
+            </a:r>
+          </a:p>
+          <a:p>
+            <a:pPr lvl="1"/>
+            <a:r>
+              <a:rPr lang="en-US" dirty="0"/>
+              <a:t>Automated issue creation and tracking via GitHub’s </a:t>
+            </a:r>
+            <a:r>
+              <a:rPr lang="en-US" dirty="0" err="1"/>
+              <a:t>GraphQL</a:t>
+            </a:r>
+            <a:r>
+              <a:rPr lang="en-US" dirty="0"/>
+              <a:t> API</a:t>
+            </a:r>
+          </a:p>
+          <a:p>
+            <a:r>
+              <a:rPr lang="en-US" dirty="0"/>
+              <a:t>Workflow</a:t>
+            </a:r>
+          </a:p>
+          <a:p>
+            <a:pPr lvl="1"/>
+            <a:r>
+              <a:rPr lang="en-US" dirty="0"/>
+              <a:t>Internal teams fill out a simplified web form that collects relevant data</a:t>
+            </a:r>
+          </a:p>
+          <a:p>
+            <a:pPr lvl="1"/>
+            <a:r>
+              <a:rPr lang="en-US" dirty="0"/>
+              <a:t>Uses </a:t>
+            </a:r>
+            <a:r>
+              <a:rPr lang="en-US" dirty="0" err="1"/>
+              <a:t>GraphQL</a:t>
+            </a:r>
+            <a:r>
+              <a:rPr lang="en-US" dirty="0"/>
+              <a:t> API to automatically open draft issues to be reviewed by the team</a:t>
+            </a:r>
+          </a:p>
+          <a:p>
+            <a:pPr lvl="1"/>
+            <a:r>
+              <a:rPr lang="en-US" dirty="0"/>
+              <a:t>Can direct to S-Drive, other links/images etc.</a:t>
+            </a:r>
+          </a:p>
+        </p:txBody>
+      </p:sp>
+      <p:sp>
+        <p:nvSpPr>
+          <p:cNvPr id="4" name="Slide Number Placeholder 3">
+            <a:extLst>
+              <a:ext uri="{FF2B5EF4-FFF2-40B4-BE49-F238E27FC236}">
+                <a16:creationId xmlns:a16="http://schemas.microsoft.com/office/drawing/2014/main" id="{2532A56D-670D-E0AE-D5EC-652EA55F0CBA}"/>
+              </a:ext>
+            </a:extLst>
+          </p:cNvPr>
+          <p:cNvSpPr>
+            <a:spLocks noGrp="1"/>
+          </p:cNvSpPr>
+          <p:nvPr>
+            <p:ph type="sldNum" sz="quarter" idx="12"/>
+          </p:nvPr>
+        </p:nvSpPr>
+        <p:spPr/>
+        <p:txBody>
+          <a:bodyPr/>
+          <a:lstStyle/>
+          <a:p>
+            <a:fld id="{7B8EE3F9-A947-5A4C-873E-0A1944126D5A}" type="slidenum">
+              <a:rPr lang="en-US" smtClean="0"/>
+              <a:pPr/>
+              <a:t>6</a:t>
+            </a:fld>
+            <a:endParaRPr lang="en-US"/>
+          </a:p>
+        </p:txBody>
+      </p:sp>
+    </p:spTree>
+    <p:extLst>
+      <p:ext uri="{BB962C8B-B14F-4D97-AF65-F5344CB8AC3E}">
+        <p14:creationId xmlns:p14="http://schemas.microsoft.com/office/powerpoint/2010/main" val="1578293888"/>
       </p:ext>
     </p:extLst>
   </p:cSld>
@@ -19258,7 +18813,13 @@
   <p:cSld>
     <p:spTree>
       <p:nvGrpSpPr>
-        <p:cNvPr id="1" name=""/>
+        <p:cNvPr id="1" name="">
+          <a:extLst>
+            <a:ext uri="{FF2B5EF4-FFF2-40B4-BE49-F238E27FC236}">
+              <a16:creationId xmlns:a16="http://schemas.microsoft.com/office/drawing/2014/main" id="{4D7C032C-6330-1ED0-B57D-E79E5236F952}"/>
+            </a:ext>
+          </a:extLst>
+        </p:cNvPr>
         <p:cNvGrpSpPr/>
         <p:nvPr/>
       </p:nvGrpSpPr>
@@ -19272,10 +18833,183 @@
       </p:grpSpPr>
       <p:sp>
         <p:nvSpPr>
-          <p:cNvPr id="2" name="Slide Number Placeholder 1">
+          <p:cNvPr id="5" name="Title 4">
             <a:extLst>
               <a:ext uri="{FF2B5EF4-FFF2-40B4-BE49-F238E27FC236}">
-                <a16:creationId xmlns:a16="http://schemas.microsoft.com/office/drawing/2014/main" id="{D711F838-935D-7C6B-F588-7C93C366CEF8}"/>
+                <a16:creationId xmlns:a16="http://schemas.microsoft.com/office/drawing/2014/main" id="{31ECC004-1756-691E-C052-68E6F274BAFA}"/>
+              </a:ext>
+            </a:extLst>
+          </p:cNvPr>
+          <p:cNvSpPr>
+            <a:spLocks noGrp="1"/>
+          </p:cNvSpPr>
+          <p:nvPr>
+            <p:ph type="title"/>
+          </p:nvPr>
+        </p:nvSpPr>
+        <p:spPr/>
+        <p:txBody>
+          <a:bodyPr/>
+          <a:lstStyle/>
+          <a:p>
+            <a:r>
+              <a:rPr lang="en-US" dirty="0"/>
+              <a:t>Next Step: Middleware</a:t>
+            </a:r>
+          </a:p>
+        </p:txBody>
+      </p:sp>
+      <p:sp>
+        <p:nvSpPr>
+          <p:cNvPr id="6" name="Content Placeholder 5">
+            <a:extLst>
+              <a:ext uri="{FF2B5EF4-FFF2-40B4-BE49-F238E27FC236}">
+                <a16:creationId xmlns:a16="http://schemas.microsoft.com/office/drawing/2014/main" id="{094BB1D5-B50C-F5E6-7A87-AB5EA61502DB}"/>
+              </a:ext>
+            </a:extLst>
+          </p:cNvPr>
+          <p:cNvSpPr>
+            <a:spLocks noGrp="1"/>
+          </p:cNvSpPr>
+          <p:nvPr>
+            <p:ph idx="1"/>
+          </p:nvPr>
+        </p:nvSpPr>
+        <p:spPr>
+          <a:xfrm>
+            <a:off x="501042" y="1244621"/>
+            <a:ext cx="11304740" cy="4923198"/>
+          </a:xfrm>
+        </p:spPr>
+        <p:txBody>
+          <a:bodyPr/>
+          <a:lstStyle/>
+          <a:p>
+            <a:pPr marL="0" indent="0">
+              <a:buNone/>
+            </a:pPr>
+            <a:r>
+              <a:rPr lang="en-US" dirty="0"/>
+              <a:t>To make this system functional, </a:t>
+            </a:r>
+            <a:r>
+              <a:rPr lang="en-US" b="1" dirty="0"/>
+              <a:t>middleware</a:t>
+            </a:r>
+            <a:r>
+              <a:rPr lang="en-US" dirty="0"/>
+              <a:t> is required to act as a bridge between the internal web form and the GitHub </a:t>
+            </a:r>
+            <a:r>
+              <a:rPr lang="en-US" dirty="0" err="1"/>
+              <a:t>GraphQL</a:t>
+            </a:r>
+            <a:r>
+              <a:rPr lang="en-US" dirty="0"/>
+              <a:t> API. However, there are several implementation decisions to address:</a:t>
+            </a:r>
+          </a:p>
+          <a:p>
+            <a:r>
+              <a:rPr lang="en-US" dirty="0"/>
+              <a:t>Main Concern: Storage of GitHub PAT</a:t>
+            </a:r>
+          </a:p>
+          <a:p>
+            <a:pPr lvl="1"/>
+            <a:r>
+              <a:rPr lang="en-US" dirty="0"/>
+              <a:t>Personal Access Tokens are required for </a:t>
+            </a:r>
+            <a:r>
+              <a:rPr lang="en-US" dirty="0" err="1"/>
+              <a:t>GraphQL</a:t>
+            </a:r>
+            <a:r>
+              <a:rPr lang="en-US" dirty="0"/>
+              <a:t> API</a:t>
+            </a:r>
+          </a:p>
+          <a:p>
+            <a:pPr lvl="1"/>
+            <a:r>
+              <a:rPr lang="en-US" dirty="0"/>
+              <a:t>Options for secure storage include</a:t>
+            </a:r>
+          </a:p>
+          <a:p>
+            <a:pPr lvl="2"/>
+            <a:r>
+              <a:rPr lang="en-US" dirty="0"/>
+              <a:t>Environment Variables</a:t>
+            </a:r>
+          </a:p>
+          <a:p>
+            <a:pPr lvl="3"/>
+            <a:r>
+              <a:rPr lang="en-US" dirty="0"/>
+              <a:t>Stored within Middleware Server’s environment variables</a:t>
+            </a:r>
+          </a:p>
+          <a:p>
+            <a:pPr lvl="2"/>
+            <a:r>
+              <a:rPr lang="en-US" dirty="0"/>
+              <a:t>Secrets Vaults?</a:t>
+            </a:r>
+          </a:p>
+          <a:p>
+            <a:pPr lvl="2"/>
+            <a:r>
+              <a:rPr lang="en-US" dirty="0"/>
+              <a:t>Token Rotation</a:t>
+            </a:r>
+          </a:p>
+          <a:p>
+            <a:pPr lvl="1"/>
+            <a:r>
+              <a:rPr lang="en-US" dirty="0"/>
+              <a:t>Middleware hosting</a:t>
+            </a:r>
+          </a:p>
+          <a:p>
+            <a:pPr lvl="2"/>
+            <a:r>
+              <a:rPr lang="en-US" dirty="0"/>
+              <a:t>Local Server using Flask or Express</a:t>
+            </a:r>
+          </a:p>
+          <a:p>
+            <a:pPr lvl="2"/>
+            <a:r>
+              <a:rPr lang="en-US" dirty="0"/>
+              <a:t>External Service</a:t>
+            </a:r>
+          </a:p>
+          <a:p>
+            <a:pPr lvl="3"/>
+            <a:r>
+              <a:rPr lang="en-US" dirty="0"/>
+              <a:t>AWS, Azure, </a:t>
+            </a:r>
+            <a:r>
+              <a:rPr lang="en-US" dirty="0" err="1"/>
+              <a:t>Vercel</a:t>
+            </a:r>
+            <a:endParaRPr lang="en-US" dirty="0"/>
+          </a:p>
+          <a:p>
+            <a:pPr lvl="1"/>
+            <a:endParaRPr lang="en-US" dirty="0"/>
+          </a:p>
+        </p:txBody>
+      </p:sp>
+      <p:sp>
+        <p:nvSpPr>
+          <p:cNvPr id="4" name="Slide Number Placeholder 3">
+            <a:extLst>
+              <a:ext uri="{FF2B5EF4-FFF2-40B4-BE49-F238E27FC236}">
+                <a16:creationId xmlns:a16="http://schemas.microsoft.com/office/drawing/2014/main" id="{71E0C3A7-0429-8C90-DB19-51564BF0E67F}"/>
               </a:ext>
             </a:extLst>
           </p:cNvPr>
@@ -19300,35 +19034,10 @@
           </a:p>
         </p:txBody>
       </p:sp>
-      <p:sp>
-        <p:nvSpPr>
-          <p:cNvPr id="4" name="Title 3">
-            <a:extLst>
-              <a:ext uri="{FF2B5EF4-FFF2-40B4-BE49-F238E27FC236}">
-                <a16:creationId xmlns:a16="http://schemas.microsoft.com/office/drawing/2014/main" id="{9DC98DE8-FB62-B475-38CE-17DB25BB0E7A}"/>
-              </a:ext>
-            </a:extLst>
-          </p:cNvPr>
-          <p:cNvSpPr>
-            <a:spLocks noGrp="1"/>
-          </p:cNvSpPr>
-          <p:nvPr>
-            <p:ph type="title"/>
-          </p:nvPr>
-        </p:nvSpPr>
-        <p:spPr/>
-        <p:txBody>
-          <a:bodyPr/>
-          <a:lstStyle/>
-          <a:p>
-            <a:endParaRPr lang="en-US"/>
-          </a:p>
-        </p:txBody>
-      </p:sp>
     </p:spTree>
     <p:extLst>
       <p:ext uri="{BB962C8B-B14F-4D97-AF65-F5344CB8AC3E}">
-        <p14:creationId xmlns:p14="http://schemas.microsoft.com/office/powerpoint/2010/main" val="3853397660"/>
+        <p14:creationId xmlns:p14="http://schemas.microsoft.com/office/powerpoint/2010/main" val="3398879504"/>
       </p:ext>
     </p:extLst>
   </p:cSld>
@@ -19355,148 +19064,10 @@
           <a:chExt cx="0" cy="0"/>
         </a:xfrm>
       </p:grpSpPr>
-      <p:sp>
-        <p:nvSpPr>
-          <p:cNvPr id="4" name="Title 3">
-            <a:extLst>
-              <a:ext uri="{FF2B5EF4-FFF2-40B4-BE49-F238E27FC236}">
-                <a16:creationId xmlns:a16="http://schemas.microsoft.com/office/drawing/2014/main" id="{7C007040-3AAE-DAC0-D01F-E7DC0B8D4D42}"/>
-              </a:ext>
-            </a:extLst>
-          </p:cNvPr>
-          <p:cNvSpPr>
-            <a:spLocks noGrp="1"/>
-          </p:cNvSpPr>
-          <p:nvPr>
-            <p:ph type="title"/>
-          </p:nvPr>
-        </p:nvSpPr>
-        <p:spPr/>
-        <p:txBody>
-          <a:bodyPr/>
-          <a:lstStyle/>
-          <a:p>
-            <a:endParaRPr lang="en-US"/>
-          </a:p>
-        </p:txBody>
-      </p:sp>
-      <p:sp>
-        <p:nvSpPr>
-          <p:cNvPr id="2" name="Slide Number Placeholder 1">
-            <a:extLst>
-              <a:ext uri="{FF2B5EF4-FFF2-40B4-BE49-F238E27FC236}">
-                <a16:creationId xmlns:a16="http://schemas.microsoft.com/office/drawing/2014/main" id="{376CEE4F-1D1D-3BB7-2CB6-5F4D2A37E6D3}"/>
-              </a:ext>
-            </a:extLst>
-          </p:cNvPr>
-          <p:cNvSpPr>
-            <a:spLocks noGrp="1"/>
-          </p:cNvSpPr>
-          <p:nvPr>
-            <p:ph type="sldNum" sz="quarter" idx="12"/>
-          </p:nvPr>
-        </p:nvSpPr>
-        <p:spPr/>
-        <p:txBody>
-          <a:bodyPr/>
-          <a:lstStyle/>
-          <a:p>
-            <a:fld id="{7B8EE3F9-A947-5A4C-873E-0A1944126D5A}" type="slidenum">
-              <a:rPr lang="en-US" smtClean="0"/>
-              <a:t>8</a:t>
-            </a:fld>
-            <a:endParaRPr lang="en-US"/>
-          </a:p>
-        </p:txBody>
-      </p:sp>
     </p:spTree>
     <p:extLst>
       <p:ext uri="{BB962C8B-B14F-4D97-AF65-F5344CB8AC3E}">
-        <p14:creationId xmlns:p14="http://schemas.microsoft.com/office/powerpoint/2010/main" val="1626552125"/>
-      </p:ext>
-    </p:extLst>
-  </p:cSld>
-  <p:clrMapOvr>
-    <a:masterClrMapping/>
-  </p:clrMapOvr>
-</p:sld>
-</file>
-
-<file path=ppt/slides/slide9.xml><?xml version="1.0" encoding="utf-8"?>
-<p:sld xmlns:a="http://schemas.openxmlformats.org/drawingml/2006/main" xmlns:r="http://schemas.openxmlformats.org/officeDocument/2006/relationships" xmlns:p="http://schemas.openxmlformats.org/presentationml/2006/main">
-  <p:cSld>
-    <p:spTree>
-      <p:nvGrpSpPr>
-        <p:cNvPr id="1" name=""/>
-        <p:cNvGrpSpPr/>
-        <p:nvPr/>
-      </p:nvGrpSpPr>
-      <p:grpSpPr>
-        <a:xfrm>
-          <a:off x="0" y="0"/>
-          <a:ext cx="0" cy="0"/>
-          <a:chOff x="0" y="0"/>
-          <a:chExt cx="0" cy="0"/>
-        </a:xfrm>
-      </p:grpSpPr>
-      <p:sp>
-        <p:nvSpPr>
-          <p:cNvPr id="4" name="Title 3">
-            <a:extLst>
-              <a:ext uri="{FF2B5EF4-FFF2-40B4-BE49-F238E27FC236}">
-                <a16:creationId xmlns:a16="http://schemas.microsoft.com/office/drawing/2014/main" id="{7C2C5D66-155B-FFE2-58F3-3E8D42EA886E}"/>
-              </a:ext>
-            </a:extLst>
-          </p:cNvPr>
-          <p:cNvSpPr>
-            <a:spLocks noGrp="1"/>
-          </p:cNvSpPr>
-          <p:nvPr>
-            <p:ph type="title"/>
-          </p:nvPr>
-        </p:nvSpPr>
-        <p:spPr/>
-        <p:txBody>
-          <a:bodyPr/>
-          <a:lstStyle/>
-          <a:p>
-            <a:endParaRPr lang="en-US"/>
-          </a:p>
-        </p:txBody>
-      </p:sp>
-      <p:sp>
-        <p:nvSpPr>
-          <p:cNvPr id="3" name="Slide Number Placeholder 2">
-            <a:extLst>
-              <a:ext uri="{FF2B5EF4-FFF2-40B4-BE49-F238E27FC236}">
-                <a16:creationId xmlns:a16="http://schemas.microsoft.com/office/drawing/2014/main" id="{D17D91F6-3B7D-B2A9-3145-224260C51D44}"/>
-              </a:ext>
-            </a:extLst>
-          </p:cNvPr>
-          <p:cNvSpPr>
-            <a:spLocks noGrp="1"/>
-          </p:cNvSpPr>
-          <p:nvPr>
-            <p:ph type="sldNum" sz="quarter" idx="12"/>
-          </p:nvPr>
-        </p:nvSpPr>
-        <p:spPr/>
-        <p:txBody>
-          <a:bodyPr/>
-          <a:lstStyle/>
-          <a:p>
-            <a:fld id="{7B8EE3F9-A947-5A4C-873E-0A1944126D5A}" type="slidenum">
-              <a:rPr lang="en-US" smtClean="0"/>
-              <a:t>9</a:t>
-            </a:fld>
-            <a:endParaRPr lang="en-US"/>
-          </a:p>
-        </p:txBody>
-      </p:sp>
-    </p:spTree>
-    <p:extLst>
-      <p:ext uri="{BB962C8B-B14F-4D97-AF65-F5344CB8AC3E}">
-        <p14:creationId xmlns:p14="http://schemas.microsoft.com/office/powerpoint/2010/main" val="903948017"/>
+        <p14:creationId xmlns:p14="http://schemas.microsoft.com/office/powerpoint/2010/main" val="569995853"/>
       </p:ext>
     </p:extLst>
   </p:cSld>
@@ -20003,6 +19574,26 @@
 </file>
 
 <file path=customXml/item1.xml><?xml version="1.0" encoding="utf-8"?>
+<p:properties xmlns:p="http://schemas.microsoft.com/office/2006/metadata/properties" xmlns:xsi="http://www.w3.org/2001/XMLSchema-instance" xmlns:pc="http://schemas.microsoft.com/office/infopath/2007/PartnerControls">
+  <documentManagement>
+    <lcf76f155ced4ddcb4097134ff3c332f xmlns="d83e99b4-c0ca-492e-a09e-bf7b8e4c70cc">
+      <Terms xmlns="http://schemas.microsoft.com/office/infopath/2007/PartnerControls"/>
+    </lcf76f155ced4ddcb4097134ff3c332f>
+    <TaxCatchAll xmlns="cad5c0e3-fdba-40f9-b545-30aff7684e19" xsi:nil="true"/>
+  </documentManagement>
+</p:properties>
+</file>
+
+<file path=customXml/item2.xml><?xml version="1.0" encoding="utf-8"?>
+<?mso-contentType ?>
+<FormTemplates xmlns="http://schemas.microsoft.com/sharepoint/v3/contenttype/forms">
+  <Display>DocumentLibraryForm</Display>
+  <Edit>DocumentLibraryForm</Edit>
+  <New>DocumentLibraryForm</New>
+</FormTemplates>
+</file>
+
+<file path=customXml/item3.xml><?xml version="1.0" encoding="utf-8"?>
 <ct:contentTypeSchema xmlns:ct="http://schemas.microsoft.com/office/2006/metadata/contentType" xmlns:ma="http://schemas.microsoft.com/office/2006/metadata/properties/metaAttributes" ct:_="" ma:_="" ma:contentTypeName="Document" ma:contentTypeID="0x01010034C9B68FAE5EFF409E9CF163E5D6F070" ma:contentTypeVersion="11" ma:contentTypeDescription="Create a new document." ma:contentTypeScope="" ma:versionID="07368b14781012e06c5971056b7de944">
   <xsd:schema xmlns:xsd="http://www.w3.org/2001/XMLSchema" xmlns:xs="http://www.w3.org/2001/XMLSchema" xmlns:p="http://schemas.microsoft.com/office/2006/metadata/properties" xmlns:ns2="d83e99b4-c0ca-492e-a09e-bf7b8e4c70cc" xmlns:ns3="cad5c0e3-fdba-40f9-b545-30aff7684e19" targetNamespace="http://schemas.microsoft.com/office/2006/metadata/properties" ma:root="true" ma:fieldsID="adb4f500bb2a140cf6623c23a33ba680" ns2:_="" ns3:_="">
     <xsd:import namespace="d83e99b4-c0ca-492e-a09e-bf7b8e4c70cc"/>
@@ -20197,27 +19788,32 @@
 </ct:contentTypeSchema>
 </file>
 
-<file path=customXml/item2.xml><?xml version="1.0" encoding="utf-8"?>
-<?mso-contentType ?>
-<FormTemplates xmlns="http://schemas.microsoft.com/sharepoint/v3/contenttype/forms">
-  <Display>DocumentLibraryForm</Display>
-  <Edit>DocumentLibraryForm</Edit>
-  <New>DocumentLibraryForm</New>
-</FormTemplates>
+<file path=customXml/itemProps1.xml><?xml version="1.0" encoding="utf-8"?>
+<ds:datastoreItem xmlns:ds="http://schemas.openxmlformats.org/officeDocument/2006/customXml" ds:itemID="{1D815FFD-AE6E-4604-922C-B8B7C194B357}">
+  <ds:schemaRefs>
+    <ds:schemaRef ds:uri="cad5c0e3-fdba-40f9-b545-30aff7684e19"/>
+    <ds:schemaRef ds:uri="d83e99b4-c0ca-492e-a09e-bf7b8e4c70cc"/>
+    <ds:schemaRef ds:uri="http://purl.org/dc/dcmitype/"/>
+    <ds:schemaRef ds:uri="http://purl.org/dc/elements/1.1/"/>
+    <ds:schemaRef ds:uri="http://purl.org/dc/terms/"/>
+    <ds:schemaRef ds:uri="http://schemas.microsoft.com/office/2006/documentManagement/types"/>
+    <ds:schemaRef ds:uri="http://schemas.microsoft.com/office/2006/metadata/properties"/>
+    <ds:schemaRef ds:uri="http://schemas.microsoft.com/office/infopath/2007/PartnerControls"/>
+    <ds:schemaRef ds:uri="http://schemas.openxmlformats.org/package/2006/metadata/core-properties"/>
+    <ds:schemaRef ds:uri="http://www.w3.org/XML/1998/namespace"/>
+  </ds:schemaRefs>
+</ds:datastoreItem>
 </file>
 
-<file path=customXml/item3.xml><?xml version="1.0" encoding="utf-8"?>
-<p:properties xmlns:p="http://schemas.microsoft.com/office/2006/metadata/properties" xmlns:xsi="http://www.w3.org/2001/XMLSchema-instance" xmlns:pc="http://schemas.microsoft.com/office/infopath/2007/PartnerControls">
-  <documentManagement>
-    <lcf76f155ced4ddcb4097134ff3c332f xmlns="d83e99b4-c0ca-492e-a09e-bf7b8e4c70cc">
-      <Terms xmlns="http://schemas.microsoft.com/office/infopath/2007/PartnerControls"/>
-    </lcf76f155ced4ddcb4097134ff3c332f>
-    <TaxCatchAll xmlns="cad5c0e3-fdba-40f9-b545-30aff7684e19" xsi:nil="true"/>
-  </documentManagement>
-</p:properties>
+<file path=customXml/itemProps2.xml><?xml version="1.0" encoding="utf-8"?>
+<ds:datastoreItem xmlns:ds="http://schemas.openxmlformats.org/officeDocument/2006/customXml" ds:itemID="{38478541-5097-4409-BB08-0FAA2D483958}">
+  <ds:schemaRefs>
+    <ds:schemaRef ds:uri="http://schemas.microsoft.com/sharepoint/v3/contenttype/forms"/>
+  </ds:schemaRefs>
+</ds:datastoreItem>
 </file>
 
-<file path=customXml/itemProps1.xml><?xml version="1.0" encoding="utf-8"?>
+<file path=customXml/itemProps3.xml><?xml version="1.0" encoding="utf-8"?>
 <ds:datastoreItem xmlns:ds="http://schemas.openxmlformats.org/officeDocument/2006/customXml" ds:itemID="{F3C44FB6-DB25-4148-9564-4A8FBD81DAA1}">
   <ds:schemaRefs>
     <ds:schemaRef ds:uri="cad5c0e3-fdba-40f9-b545-30aff7684e19"/>
@@ -20234,29 +19830,4 @@
     <ds:schemaRef ds:uri="http://www.w3.org/2001/XMLSchema"/>
   </ds:schemaRefs>
 </ds:datastoreItem>
-</file>
-
-<file path=customXml/itemProps2.xml><?xml version="1.0" encoding="utf-8"?>
-<ds:datastoreItem xmlns:ds="http://schemas.openxmlformats.org/officeDocument/2006/customXml" ds:itemID="{38478541-5097-4409-BB08-0FAA2D483958}">
-  <ds:schemaRefs>
-    <ds:schemaRef ds:uri="http://schemas.microsoft.com/sharepoint/v3/contenttype/forms"/>
-  </ds:schemaRefs>
-</ds:datastoreItem>
-</file>
-
-<file path=customXml/itemProps3.xml><?xml version="1.0" encoding="utf-8"?>
-<ds:datastoreItem xmlns:ds="http://schemas.openxmlformats.org/officeDocument/2006/customXml" ds:itemID="{1D815FFD-AE6E-4604-922C-B8B7C194B357}">
-  <ds:schemaRefs>
-    <ds:schemaRef ds:uri="cad5c0e3-fdba-40f9-b545-30aff7684e19"/>
-    <ds:schemaRef ds:uri="d83e99b4-c0ca-492e-a09e-bf7b8e4c70cc"/>
-    <ds:schemaRef ds:uri="http://purl.org/dc/dcmitype/"/>
-    <ds:schemaRef ds:uri="http://purl.org/dc/elements/1.1/"/>
-    <ds:schemaRef ds:uri="http://purl.org/dc/terms/"/>
-    <ds:schemaRef ds:uri="http://schemas.microsoft.com/office/2006/documentManagement/types"/>
-    <ds:schemaRef ds:uri="http://schemas.microsoft.com/office/2006/metadata/properties"/>
-    <ds:schemaRef ds:uri="http://schemas.microsoft.com/office/infopath/2007/PartnerControls"/>
-    <ds:schemaRef ds:uri="http://schemas.openxmlformats.org/package/2006/metadata/core-properties"/>
-    <ds:schemaRef ds:uri="http://www.w3.org/XML/1998/namespace"/>
-  </ds:schemaRefs>
-</ds:datastoreItem>
 </file>
</xml_diff>